<commit_message>
updat pdf and pptx
</commit_message>
<xml_diff>
--- a/docs/Riemannian_geodesics/Figures_for_Jacobi_metric_and_Riemannian_geometry.pptx
+++ b/docs/Riemannian_geodesics/Figures_for_Jacobi_metric_and_Riemannian_geometry.pptx
@@ -3321,77 +3321,895 @@
           <a:chExt cx="0" cy="0"/>
         </a:xfrm>
       </p:grpSpPr>
-      <p:sp>
-        <p:nvSpPr>
-          <p:cNvPr id="4" name="Rounded Rectangle 3">
-            <a:extLst>
-              <a:ext uri="{FF2B5EF4-FFF2-40B4-BE49-F238E27FC236}">
-                <a16:creationId xmlns:a16="http://schemas.microsoft.com/office/drawing/2014/main" id="{3A2428F0-D6AB-E5EF-F283-D7FF95ADDD72}"/>
-              </a:ext>
-            </a:extLst>
-          </p:cNvPr>
-          <p:cNvSpPr/>
-          <p:nvPr/>
-        </p:nvSpPr>
-        <p:spPr>
-          <a:xfrm>
-            <a:off x="3191774" y="905774"/>
-            <a:ext cx="2719458" cy="647897"/>
-          </a:xfrm>
-          <a:prstGeom prst="roundRect">
-            <a:avLst/>
-          </a:prstGeom>
-          <a:solidFill>
-            <a:schemeClr val="accent5">
-              <a:alpha val="26613"/>
-            </a:schemeClr>
-          </a:solidFill>
-        </p:spPr>
-        <p:style>
-          <a:lnRef idx="2">
-            <a:schemeClr val="accent1">
-              <a:shade val="15000"/>
-            </a:schemeClr>
-          </a:lnRef>
-          <a:fillRef idx="1">
-            <a:schemeClr val="accent1"/>
-          </a:fillRef>
-          <a:effectRef idx="0">
-            <a:schemeClr val="accent1"/>
-          </a:effectRef>
-          <a:fontRef idx="minor">
-            <a:schemeClr val="lt1"/>
-          </a:fontRef>
-        </p:style>
-        <p:txBody>
-          <a:bodyPr rtlCol="0" anchor="ctr"/>
-          <a:lstStyle/>
-          <a:p>
-            <a:pPr algn="ctr"/>
-            <a:r>
-              <a:rPr lang="en-US" sz="900" dirty="0" err="1">
-                <a:solidFill>
-                  <a:schemeClr val="tx1"/>
-                </a:solidFill>
-              </a:rPr>
-              <a:t>Lagrangian</a:t>
-            </a:r>
-            <a:r>
-              <a:rPr lang="en-US" sz="900">
-                <a:solidFill>
-                  <a:schemeClr val="tx1"/>
-                </a:solidFill>
-              </a:rPr>
-              <a:t> Mechanics: </a:t>
-            </a:r>
-            <a:endParaRPr lang="en-US" sz="900" dirty="0">
+      <mc:AlternateContent xmlns:mc="http://schemas.openxmlformats.org/markup-compatibility/2006">
+        <mc:Choice xmlns:a14="http://schemas.microsoft.com/office/drawing/2010/main" Requires="a14">
+          <p:sp>
+            <p:nvSpPr>
+              <p:cNvPr id="4" name="Rounded Rectangle 3">
+                <a:extLst>
+                  <a:ext uri="{FF2B5EF4-FFF2-40B4-BE49-F238E27FC236}">
+                    <a16:creationId xmlns:a16="http://schemas.microsoft.com/office/drawing/2014/main" id="{3A2428F0-D6AB-E5EF-F283-D7FF95ADDD72}"/>
+                  </a:ext>
+                </a:extLst>
+              </p:cNvPr>
+              <p:cNvSpPr/>
+              <p:nvPr/>
+            </p:nvSpPr>
+            <p:spPr>
+              <a:xfrm>
+                <a:off x="3191774" y="905774"/>
+                <a:ext cx="2719458" cy="647897"/>
+              </a:xfrm>
+              <a:prstGeom prst="roundRect">
+                <a:avLst/>
+              </a:prstGeom>
               <a:solidFill>
-                <a:schemeClr val="tx1"/>
+                <a:schemeClr val="accent5">
+                  <a:alpha val="26613"/>
+                </a:schemeClr>
               </a:solidFill>
-            </a:endParaRPr>
-          </a:p>
-        </p:txBody>
-      </p:sp>
+            </p:spPr>
+            <p:style>
+              <a:lnRef idx="2">
+                <a:schemeClr val="accent1">
+                  <a:shade val="15000"/>
+                </a:schemeClr>
+              </a:lnRef>
+              <a:fillRef idx="1">
+                <a:schemeClr val="accent1"/>
+              </a:fillRef>
+              <a:effectRef idx="0">
+                <a:schemeClr val="accent1"/>
+              </a:effectRef>
+              <a:fontRef idx="minor">
+                <a:schemeClr val="lt1"/>
+              </a:fontRef>
+            </p:style>
+            <p:txBody>
+              <a:bodyPr rtlCol="0" anchor="ctr"/>
+              <a:lstStyle/>
+              <a:p>
+                <a:pPr algn="ctr"/>
+                <a:r>
+                  <a:rPr lang="en-US" sz="900" dirty="0">
+                    <a:solidFill>
+                      <a:schemeClr val="tx1"/>
+                    </a:solidFill>
+                  </a:rPr>
+                  <a:t>Lagrangian Mechanics</a:t>
+                </a:r>
+              </a:p>
+              <a:p>
+                <a:pPr algn="ctr"/>
+                <a14:m>
+                  <m:oMathPara xmlns:m="http://schemas.openxmlformats.org/officeDocument/2006/math">
+                    <m:oMathParaPr>
+                      <m:jc m:val="centerGroup"/>
+                    </m:oMathParaPr>
+                    <m:oMath xmlns:m="http://schemas.openxmlformats.org/officeDocument/2006/math">
+                      <m:r>
+                        <a:rPr lang="en-US" sz="900" i="1" smtClean="0">
+                          <a:solidFill>
+                            <a:schemeClr val="tx1"/>
+                          </a:solidFill>
+                          <a:latin typeface="Cambria Math" panose="02040503050406030204" pitchFamily="18" charset="0"/>
+                          <a:ea typeface="Cambria Math" panose="02040503050406030204" pitchFamily="18" charset="0"/>
+                        </a:rPr>
+                        <m:t>ℒ</m:t>
+                      </m:r>
+                      <m:d>
+                        <m:dPr>
+                          <m:ctrlPr>
+                            <a:rPr lang="en-US" sz="900" i="1" smtClean="0">
+                              <a:solidFill>
+                                <a:schemeClr val="tx1"/>
+                              </a:solidFill>
+                              <a:latin typeface="Cambria Math" panose="02040503050406030204" pitchFamily="18" charset="0"/>
+                              <a:ea typeface="Cambria Math" panose="02040503050406030204" pitchFamily="18" charset="0"/>
+                            </a:rPr>
+                          </m:ctrlPr>
+                        </m:dPr>
+                        <m:e>
+                          <m:r>
+                            <a:rPr lang="en-US" sz="900" b="0" i="1" smtClean="0">
+                              <a:solidFill>
+                                <a:schemeClr val="tx1"/>
+                              </a:solidFill>
+                              <a:latin typeface="Cambria Math" panose="02040503050406030204" pitchFamily="18" charset="0"/>
+                              <a:ea typeface="Cambria Math" panose="02040503050406030204" pitchFamily="18" charset="0"/>
+                            </a:rPr>
+                            <m:t>𝑞</m:t>
+                          </m:r>
+                          <m:r>
+                            <a:rPr lang="en-US" sz="900" b="0" i="1" smtClean="0">
+                              <a:solidFill>
+                                <a:schemeClr val="tx1"/>
+                              </a:solidFill>
+                              <a:latin typeface="Cambria Math" panose="02040503050406030204" pitchFamily="18" charset="0"/>
+                              <a:ea typeface="Cambria Math" panose="02040503050406030204" pitchFamily="18" charset="0"/>
+                            </a:rPr>
+                            <m:t>,</m:t>
+                          </m:r>
+                          <m:acc>
+                            <m:accPr>
+                              <m:chr m:val="̇"/>
+                              <m:ctrlPr>
+                                <a:rPr lang="en-US" sz="900" b="0" i="1" smtClean="0">
+                                  <a:solidFill>
+                                    <a:schemeClr val="tx1"/>
+                                  </a:solidFill>
+                                  <a:latin typeface="Cambria Math" panose="02040503050406030204" pitchFamily="18" charset="0"/>
+                                  <a:ea typeface="Cambria Math" panose="02040503050406030204" pitchFamily="18" charset="0"/>
+                                </a:rPr>
+                              </m:ctrlPr>
+                            </m:accPr>
+                            <m:e>
+                              <m:r>
+                                <a:rPr lang="en-US" sz="900" b="0" i="1" smtClean="0">
+                                  <a:solidFill>
+                                    <a:schemeClr val="tx1"/>
+                                  </a:solidFill>
+                                  <a:latin typeface="Cambria Math" panose="02040503050406030204" pitchFamily="18" charset="0"/>
+                                  <a:ea typeface="Cambria Math" panose="02040503050406030204" pitchFamily="18" charset="0"/>
+                                </a:rPr>
+                                <m:t>𝑞</m:t>
+                              </m:r>
+                            </m:e>
+                          </m:acc>
+                        </m:e>
+                      </m:d>
+                      <m:r>
+                        <a:rPr lang="en-US" sz="900" b="0" i="1" smtClean="0">
+                          <a:solidFill>
+                            <a:schemeClr val="tx1"/>
+                          </a:solidFill>
+                          <a:latin typeface="Cambria Math" panose="02040503050406030204" pitchFamily="18" charset="0"/>
+                          <a:ea typeface="Cambria Math" panose="02040503050406030204" pitchFamily="18" charset="0"/>
+                        </a:rPr>
+                        <m:t>=</m:t>
+                      </m:r>
+                      <m:r>
+                        <a:rPr lang="en-US" sz="900" b="0" i="1" smtClean="0">
+                          <a:solidFill>
+                            <a:schemeClr val="tx1"/>
+                          </a:solidFill>
+                          <a:latin typeface="Cambria Math" panose="02040503050406030204" pitchFamily="18" charset="0"/>
+                          <a:ea typeface="Cambria Math" panose="02040503050406030204" pitchFamily="18" charset="0"/>
+                        </a:rPr>
+                        <m:t>𝑇</m:t>
+                      </m:r>
+                      <m:d>
+                        <m:dPr>
+                          <m:ctrlPr>
+                            <a:rPr lang="en-US" sz="900" b="0" i="1" smtClean="0">
+                              <a:solidFill>
+                                <a:schemeClr val="tx1"/>
+                              </a:solidFill>
+                              <a:latin typeface="Cambria Math" panose="02040503050406030204" pitchFamily="18" charset="0"/>
+                              <a:ea typeface="Cambria Math" panose="02040503050406030204" pitchFamily="18" charset="0"/>
+                            </a:rPr>
+                          </m:ctrlPr>
+                        </m:dPr>
+                        <m:e>
+                          <m:r>
+                            <a:rPr lang="en-US" sz="900" b="0" i="1" smtClean="0">
+                              <a:solidFill>
+                                <a:schemeClr val="tx1"/>
+                              </a:solidFill>
+                              <a:latin typeface="Cambria Math" panose="02040503050406030204" pitchFamily="18" charset="0"/>
+                              <a:ea typeface="Cambria Math" panose="02040503050406030204" pitchFamily="18" charset="0"/>
+                            </a:rPr>
+                            <m:t>𝑞</m:t>
+                          </m:r>
+                          <m:r>
+                            <a:rPr lang="en-US" sz="900" b="0" i="1" smtClean="0">
+                              <a:solidFill>
+                                <a:schemeClr val="tx1"/>
+                              </a:solidFill>
+                              <a:latin typeface="Cambria Math" panose="02040503050406030204" pitchFamily="18" charset="0"/>
+                              <a:ea typeface="Cambria Math" panose="02040503050406030204" pitchFamily="18" charset="0"/>
+                            </a:rPr>
+                            <m:t>,</m:t>
+                          </m:r>
+                          <m:acc>
+                            <m:accPr>
+                              <m:chr m:val="̇"/>
+                              <m:ctrlPr>
+                                <a:rPr lang="en-US" sz="900" b="0" i="1" smtClean="0">
+                                  <a:solidFill>
+                                    <a:schemeClr val="tx1"/>
+                                  </a:solidFill>
+                                  <a:latin typeface="Cambria Math" panose="02040503050406030204" pitchFamily="18" charset="0"/>
+                                  <a:ea typeface="Cambria Math" panose="02040503050406030204" pitchFamily="18" charset="0"/>
+                                </a:rPr>
+                              </m:ctrlPr>
+                            </m:accPr>
+                            <m:e>
+                              <m:r>
+                                <a:rPr lang="en-US" sz="900" b="0" i="1" smtClean="0">
+                                  <a:solidFill>
+                                    <a:schemeClr val="tx1"/>
+                                  </a:solidFill>
+                                  <a:latin typeface="Cambria Math" panose="02040503050406030204" pitchFamily="18" charset="0"/>
+                                  <a:ea typeface="Cambria Math" panose="02040503050406030204" pitchFamily="18" charset="0"/>
+                                </a:rPr>
+                                <m:t>𝑞</m:t>
+                              </m:r>
+                            </m:e>
+                          </m:acc>
+                        </m:e>
+                      </m:d>
+                      <m:r>
+                        <a:rPr lang="en-US" sz="900" b="0" i="1" smtClean="0">
+                          <a:solidFill>
+                            <a:schemeClr val="tx1"/>
+                          </a:solidFill>
+                          <a:latin typeface="Cambria Math" panose="02040503050406030204" pitchFamily="18" charset="0"/>
+                          <a:ea typeface="Cambria Math" panose="02040503050406030204" pitchFamily="18" charset="0"/>
+                        </a:rPr>
+                        <m:t>−</m:t>
+                      </m:r>
+                      <m:r>
+                        <a:rPr lang="en-US" sz="900" b="0" i="1" smtClean="0">
+                          <a:solidFill>
+                            <a:schemeClr val="tx1"/>
+                          </a:solidFill>
+                          <a:latin typeface="Cambria Math" panose="02040503050406030204" pitchFamily="18" charset="0"/>
+                          <a:ea typeface="Cambria Math" panose="02040503050406030204" pitchFamily="18" charset="0"/>
+                        </a:rPr>
+                        <m:t>𝑉</m:t>
+                      </m:r>
+                      <m:d>
+                        <m:dPr>
+                          <m:ctrlPr>
+                            <a:rPr lang="en-US" sz="900" b="0" i="1" smtClean="0">
+                              <a:solidFill>
+                                <a:schemeClr val="tx1"/>
+                              </a:solidFill>
+                              <a:latin typeface="Cambria Math" panose="02040503050406030204" pitchFamily="18" charset="0"/>
+                              <a:ea typeface="Cambria Math" panose="02040503050406030204" pitchFamily="18" charset="0"/>
+                            </a:rPr>
+                          </m:ctrlPr>
+                        </m:dPr>
+                        <m:e>
+                          <m:r>
+                            <a:rPr lang="en-US" sz="900" b="0" i="1" smtClean="0">
+                              <a:solidFill>
+                                <a:schemeClr val="tx1"/>
+                              </a:solidFill>
+                              <a:latin typeface="Cambria Math" panose="02040503050406030204" pitchFamily="18" charset="0"/>
+                              <a:ea typeface="Cambria Math" panose="02040503050406030204" pitchFamily="18" charset="0"/>
+                            </a:rPr>
+                            <m:t>𝑞</m:t>
+                          </m:r>
+                        </m:e>
+                      </m:d>
+                      <m:r>
+                        <a:rPr lang="en-US" sz="900" b="0" i="1" smtClean="0">
+                          <a:solidFill>
+                            <a:schemeClr val="tx1"/>
+                          </a:solidFill>
+                          <a:latin typeface="Cambria Math" panose="02040503050406030204" pitchFamily="18" charset="0"/>
+                          <a:ea typeface="Cambria Math" panose="02040503050406030204" pitchFamily="18" charset="0"/>
+                        </a:rPr>
+                        <m:t>=</m:t>
+                      </m:r>
+                      <m:f>
+                        <m:fPr>
+                          <m:ctrlPr>
+                            <a:rPr lang="en-US" sz="900" b="0" i="1" smtClean="0">
+                              <a:solidFill>
+                                <a:schemeClr val="tx1"/>
+                              </a:solidFill>
+                              <a:latin typeface="Cambria Math" panose="02040503050406030204" pitchFamily="18" charset="0"/>
+                              <a:ea typeface="Cambria Math" panose="02040503050406030204" pitchFamily="18" charset="0"/>
+                            </a:rPr>
+                          </m:ctrlPr>
+                        </m:fPr>
+                        <m:num>
+                          <m:r>
+                            <a:rPr lang="en-US" sz="900" b="0" i="1" smtClean="0">
+                              <a:solidFill>
+                                <a:schemeClr val="tx1"/>
+                              </a:solidFill>
+                              <a:latin typeface="Cambria Math" panose="02040503050406030204" pitchFamily="18" charset="0"/>
+                              <a:ea typeface="Cambria Math" panose="02040503050406030204" pitchFamily="18" charset="0"/>
+                            </a:rPr>
+                            <m:t>1</m:t>
+                          </m:r>
+                        </m:num>
+                        <m:den>
+                          <m:r>
+                            <a:rPr lang="en-US" sz="900" b="0" i="1" smtClean="0">
+                              <a:solidFill>
+                                <a:schemeClr val="tx1"/>
+                              </a:solidFill>
+                              <a:latin typeface="Cambria Math" panose="02040503050406030204" pitchFamily="18" charset="0"/>
+                              <a:ea typeface="Cambria Math" panose="02040503050406030204" pitchFamily="18" charset="0"/>
+                            </a:rPr>
+                            <m:t>2</m:t>
+                          </m:r>
+                        </m:den>
+                      </m:f>
+                      <m:sSub>
+                        <m:sSubPr>
+                          <m:ctrlPr>
+                            <a:rPr lang="en-US" sz="900" b="0" i="1" smtClean="0">
+                              <a:solidFill>
+                                <a:schemeClr val="tx1"/>
+                              </a:solidFill>
+                              <a:latin typeface="Cambria Math" panose="02040503050406030204" pitchFamily="18" charset="0"/>
+                              <a:ea typeface="Cambria Math" panose="02040503050406030204" pitchFamily="18" charset="0"/>
+                            </a:rPr>
+                          </m:ctrlPr>
+                        </m:sSubPr>
+                        <m:e>
+                          <m:r>
+                            <a:rPr lang="en-US" sz="900" b="0" i="1" smtClean="0">
+                              <a:solidFill>
+                                <a:schemeClr val="tx1"/>
+                              </a:solidFill>
+                              <a:latin typeface="Cambria Math" panose="02040503050406030204" pitchFamily="18" charset="0"/>
+                              <a:ea typeface="Cambria Math" panose="02040503050406030204" pitchFamily="18" charset="0"/>
+                            </a:rPr>
+                            <m:t>𝑔</m:t>
+                          </m:r>
+                        </m:e>
+                        <m:sub>
+                          <m:r>
+                            <a:rPr lang="en-US" sz="900" b="0" i="1" smtClean="0">
+                              <a:solidFill>
+                                <a:schemeClr val="tx1"/>
+                              </a:solidFill>
+                              <a:latin typeface="Cambria Math" panose="02040503050406030204" pitchFamily="18" charset="0"/>
+                              <a:ea typeface="Cambria Math" panose="02040503050406030204" pitchFamily="18" charset="0"/>
+                            </a:rPr>
+                            <m:t>𝑖𝑗</m:t>
+                          </m:r>
+                        </m:sub>
+                      </m:sSub>
+                      <m:sSup>
+                        <m:sSupPr>
+                          <m:ctrlPr>
+                            <a:rPr lang="en-US" sz="900" b="0" i="1" smtClean="0">
+                              <a:solidFill>
+                                <a:schemeClr val="tx1"/>
+                              </a:solidFill>
+                              <a:latin typeface="Cambria Math" panose="02040503050406030204" pitchFamily="18" charset="0"/>
+                              <a:ea typeface="Cambria Math" panose="02040503050406030204" pitchFamily="18" charset="0"/>
+                            </a:rPr>
+                          </m:ctrlPr>
+                        </m:sSupPr>
+                        <m:e>
+                          <m:acc>
+                            <m:accPr>
+                              <m:chr m:val="̇"/>
+                              <m:ctrlPr>
+                                <a:rPr lang="en-US" sz="900" b="0" i="1" smtClean="0">
+                                  <a:solidFill>
+                                    <a:schemeClr val="tx1"/>
+                                  </a:solidFill>
+                                  <a:latin typeface="Cambria Math" panose="02040503050406030204" pitchFamily="18" charset="0"/>
+                                  <a:ea typeface="Cambria Math" panose="02040503050406030204" pitchFamily="18" charset="0"/>
+                                </a:rPr>
+                              </m:ctrlPr>
+                            </m:accPr>
+                            <m:e>
+                              <m:r>
+                                <a:rPr lang="en-US" sz="900" b="0" i="1" smtClean="0">
+                                  <a:solidFill>
+                                    <a:schemeClr val="tx1"/>
+                                  </a:solidFill>
+                                  <a:latin typeface="Cambria Math" panose="02040503050406030204" pitchFamily="18" charset="0"/>
+                                  <a:ea typeface="Cambria Math" panose="02040503050406030204" pitchFamily="18" charset="0"/>
+                                </a:rPr>
+                                <m:t>𝑞</m:t>
+                              </m:r>
+                            </m:e>
+                          </m:acc>
+                        </m:e>
+                        <m:sup>
+                          <m:r>
+                            <a:rPr lang="en-US" sz="900" b="0" i="1" smtClean="0">
+                              <a:solidFill>
+                                <a:schemeClr val="tx1"/>
+                              </a:solidFill>
+                              <a:latin typeface="Cambria Math" panose="02040503050406030204" pitchFamily="18" charset="0"/>
+                              <a:ea typeface="Cambria Math" panose="02040503050406030204" pitchFamily="18" charset="0"/>
+                            </a:rPr>
+                            <m:t>𝑖</m:t>
+                          </m:r>
+                        </m:sup>
+                      </m:sSup>
+                      <m:sSup>
+                        <m:sSupPr>
+                          <m:ctrlPr>
+                            <a:rPr lang="en-US" sz="900" b="0" i="1" smtClean="0">
+                              <a:solidFill>
+                                <a:schemeClr val="tx1"/>
+                              </a:solidFill>
+                              <a:latin typeface="Cambria Math" panose="02040503050406030204" pitchFamily="18" charset="0"/>
+                              <a:ea typeface="Cambria Math" panose="02040503050406030204" pitchFamily="18" charset="0"/>
+                            </a:rPr>
+                          </m:ctrlPr>
+                        </m:sSupPr>
+                        <m:e>
+                          <m:acc>
+                            <m:accPr>
+                              <m:chr m:val="̇"/>
+                              <m:ctrlPr>
+                                <a:rPr lang="en-US" sz="900" b="0" i="1" smtClean="0">
+                                  <a:solidFill>
+                                    <a:schemeClr val="tx1"/>
+                                  </a:solidFill>
+                                  <a:latin typeface="Cambria Math" panose="02040503050406030204" pitchFamily="18" charset="0"/>
+                                  <a:ea typeface="Cambria Math" panose="02040503050406030204" pitchFamily="18" charset="0"/>
+                                </a:rPr>
+                              </m:ctrlPr>
+                            </m:accPr>
+                            <m:e>
+                              <m:r>
+                                <a:rPr lang="en-US" sz="900" b="0" i="1" smtClean="0">
+                                  <a:solidFill>
+                                    <a:schemeClr val="tx1"/>
+                                  </a:solidFill>
+                                  <a:latin typeface="Cambria Math" panose="02040503050406030204" pitchFamily="18" charset="0"/>
+                                  <a:ea typeface="Cambria Math" panose="02040503050406030204" pitchFamily="18" charset="0"/>
+                                </a:rPr>
+                                <m:t>𝑞</m:t>
+                              </m:r>
+                            </m:e>
+                          </m:acc>
+                        </m:e>
+                        <m:sup>
+                          <m:r>
+                            <a:rPr lang="en-US" sz="900" b="0" i="1" smtClean="0">
+                              <a:solidFill>
+                                <a:schemeClr val="tx1"/>
+                              </a:solidFill>
+                              <a:latin typeface="Cambria Math" panose="02040503050406030204" pitchFamily="18" charset="0"/>
+                              <a:ea typeface="Cambria Math" panose="02040503050406030204" pitchFamily="18" charset="0"/>
+                            </a:rPr>
+                            <m:t>𝑗</m:t>
+                          </m:r>
+                        </m:sup>
+                      </m:sSup>
+                      <m:r>
+                        <a:rPr lang="en-US" sz="900" b="0" i="1" smtClean="0">
+                          <a:solidFill>
+                            <a:schemeClr val="tx1"/>
+                          </a:solidFill>
+                          <a:latin typeface="Cambria Math" panose="02040503050406030204" pitchFamily="18" charset="0"/>
+                          <a:ea typeface="Cambria Math" panose="02040503050406030204" pitchFamily="18" charset="0"/>
+                        </a:rPr>
+                        <m:t>−</m:t>
+                      </m:r>
+                      <m:r>
+                        <a:rPr lang="en-US" sz="900" b="0" i="1" smtClean="0">
+                          <a:solidFill>
+                            <a:schemeClr val="tx1"/>
+                          </a:solidFill>
+                          <a:latin typeface="Cambria Math" panose="02040503050406030204" pitchFamily="18" charset="0"/>
+                          <a:ea typeface="Cambria Math" panose="02040503050406030204" pitchFamily="18" charset="0"/>
+                        </a:rPr>
+                        <m:t>𝑉</m:t>
+                      </m:r>
+                      <m:d>
+                        <m:dPr>
+                          <m:ctrlPr>
+                            <a:rPr lang="en-US" sz="900" b="0" i="1" smtClean="0">
+                              <a:solidFill>
+                                <a:schemeClr val="tx1"/>
+                              </a:solidFill>
+                              <a:latin typeface="Cambria Math" panose="02040503050406030204" pitchFamily="18" charset="0"/>
+                              <a:ea typeface="Cambria Math" panose="02040503050406030204" pitchFamily="18" charset="0"/>
+                            </a:rPr>
+                          </m:ctrlPr>
+                        </m:dPr>
+                        <m:e>
+                          <m:r>
+                            <a:rPr lang="en-US" sz="900" b="0" i="1" smtClean="0">
+                              <a:solidFill>
+                                <a:schemeClr val="tx1"/>
+                              </a:solidFill>
+                              <a:latin typeface="Cambria Math" panose="02040503050406030204" pitchFamily="18" charset="0"/>
+                              <a:ea typeface="Cambria Math" panose="02040503050406030204" pitchFamily="18" charset="0"/>
+                            </a:rPr>
+                            <m:t>𝑞</m:t>
+                          </m:r>
+                        </m:e>
+                      </m:d>
+                    </m:oMath>
+                  </m:oMathPara>
+                </a14:m>
+                <a:endParaRPr lang="en-US" sz="900" dirty="0">
+                  <a:solidFill>
+                    <a:schemeClr val="tx1"/>
+                  </a:solidFill>
+                </a:endParaRPr>
+              </a:p>
+            </p:txBody>
+          </p:sp>
+        </mc:Choice>
+        <mc:Fallback>
+          <p:sp>
+            <p:nvSpPr>
+              <p:cNvPr id="4" name="Rounded Rectangle 3">
+                <a:extLst>
+                  <a:ext uri="{FF2B5EF4-FFF2-40B4-BE49-F238E27FC236}">
+                    <a16:creationId xmlns:a16="http://schemas.microsoft.com/office/drawing/2014/main" id="{3A2428F0-D6AB-E5EF-F283-D7FF95ADDD72}"/>
+                  </a:ext>
+                </a:extLst>
+              </p:cNvPr>
+              <p:cNvSpPr>
+                <a:spLocks noRot="1" noChangeAspect="1" noMove="1" noResize="1" noEditPoints="1" noAdjustHandles="1" noChangeArrowheads="1" noChangeShapeType="1" noTextEdit="1"/>
+              </p:cNvSpPr>
+              <p:nvPr/>
+            </p:nvSpPr>
+            <p:spPr>
+              <a:xfrm>
+                <a:off x="3191774" y="905774"/>
+                <a:ext cx="2719458" cy="647897"/>
+              </a:xfrm>
+              <a:prstGeom prst="roundRect">
+                <a:avLst/>
+              </a:prstGeom>
+              <a:blipFill>
+                <a:blip r:embed="rId2"/>
+                <a:stretch>
+                  <a:fillRect/>
+                </a:stretch>
+              </a:blipFill>
+            </p:spPr>
+            <p:txBody>
+              <a:bodyPr/>
+              <a:lstStyle/>
+              <a:p>
+                <a:r>
+                  <a:rPr lang="en-US">
+                    <a:noFill/>
+                  </a:rPr>
+                  <a:t> </a:t>
+                </a:r>
+              </a:p>
+            </p:txBody>
+          </p:sp>
+        </mc:Fallback>
+      </mc:AlternateContent>
+      <mc:AlternateContent xmlns:mc="http://schemas.openxmlformats.org/markup-compatibility/2006">
+        <mc:Choice xmlns:a14="http://schemas.microsoft.com/office/drawing/2010/main" Requires="a14">
+          <p:sp>
+            <p:nvSpPr>
+              <p:cNvPr id="5" name="Rounded Rectangle 4">
+                <a:extLst>
+                  <a:ext uri="{FF2B5EF4-FFF2-40B4-BE49-F238E27FC236}">
+                    <a16:creationId xmlns:a16="http://schemas.microsoft.com/office/drawing/2014/main" id="{2EF0B5C9-B2FD-4957-5E8C-9A5AFBF2EF3A}"/>
+                  </a:ext>
+                </a:extLst>
+              </p:cNvPr>
+              <p:cNvSpPr/>
+              <p:nvPr/>
+            </p:nvSpPr>
+            <p:spPr>
+              <a:xfrm>
+                <a:off x="3191774" y="2013034"/>
+                <a:ext cx="2719458" cy="647897"/>
+              </a:xfrm>
+              <a:prstGeom prst="roundRect">
+                <a:avLst/>
+              </a:prstGeom>
+              <a:solidFill>
+                <a:srgbClr val="949318">
+                  <a:alpha val="25882"/>
+                </a:srgbClr>
+              </a:solidFill>
+            </p:spPr>
+            <p:style>
+              <a:lnRef idx="2">
+                <a:schemeClr val="accent1">
+                  <a:shade val="15000"/>
+                </a:schemeClr>
+              </a:lnRef>
+              <a:fillRef idx="1">
+                <a:schemeClr val="accent1"/>
+              </a:fillRef>
+              <a:effectRef idx="0">
+                <a:schemeClr val="accent1"/>
+              </a:effectRef>
+              <a:fontRef idx="minor">
+                <a:schemeClr val="lt1"/>
+              </a:fontRef>
+            </p:style>
+            <p:txBody>
+              <a:bodyPr rtlCol="0" anchor="ctr"/>
+              <a:lstStyle/>
+              <a:p>
+                <a:pPr algn="ctr"/>
+                <a:r>
+                  <a:rPr lang="en-US" sz="900" dirty="0">
+                    <a:solidFill>
+                      <a:schemeClr val="tx1"/>
+                    </a:solidFill>
+                  </a:rPr>
+                  <a:t>Energy Conservation</a:t>
+                </a:r>
+              </a:p>
+              <a:p>
+                <a:pPr algn="ctr"/>
+                <a14:m>
+                  <m:oMathPara xmlns:m="http://schemas.openxmlformats.org/officeDocument/2006/math">
+                    <m:oMathParaPr>
+                      <m:jc m:val="centerGroup"/>
+                    </m:oMathParaPr>
+                    <m:oMath xmlns:m="http://schemas.openxmlformats.org/officeDocument/2006/math">
+                      <m:r>
+                        <a:rPr lang="en-US" sz="900" b="0" i="1" smtClean="0">
+                          <a:solidFill>
+                            <a:schemeClr val="tx1"/>
+                          </a:solidFill>
+                          <a:latin typeface="Cambria Math" panose="02040503050406030204" pitchFamily="18" charset="0"/>
+                          <a:ea typeface="Cambria Math" panose="02040503050406030204" pitchFamily="18" charset="0"/>
+                        </a:rPr>
+                        <m:t>𝑇</m:t>
+                      </m:r>
+                      <m:d>
+                        <m:dPr>
+                          <m:ctrlPr>
+                            <a:rPr lang="en-US" sz="900" b="0" i="1" smtClean="0">
+                              <a:solidFill>
+                                <a:schemeClr val="tx1"/>
+                              </a:solidFill>
+                              <a:latin typeface="Cambria Math" panose="02040503050406030204" pitchFamily="18" charset="0"/>
+                              <a:ea typeface="Cambria Math" panose="02040503050406030204" pitchFamily="18" charset="0"/>
+                            </a:rPr>
+                          </m:ctrlPr>
+                        </m:dPr>
+                        <m:e>
+                          <m:r>
+                            <a:rPr lang="en-US" sz="900" b="0" i="1" smtClean="0">
+                              <a:solidFill>
+                                <a:schemeClr val="tx1"/>
+                              </a:solidFill>
+                              <a:latin typeface="Cambria Math" panose="02040503050406030204" pitchFamily="18" charset="0"/>
+                              <a:ea typeface="Cambria Math" panose="02040503050406030204" pitchFamily="18" charset="0"/>
+                            </a:rPr>
+                            <m:t>𝑞</m:t>
+                          </m:r>
+                          <m:r>
+                            <a:rPr lang="en-US" sz="900" b="0" i="1" smtClean="0">
+                              <a:solidFill>
+                                <a:schemeClr val="tx1"/>
+                              </a:solidFill>
+                              <a:latin typeface="Cambria Math" panose="02040503050406030204" pitchFamily="18" charset="0"/>
+                              <a:ea typeface="Cambria Math" panose="02040503050406030204" pitchFamily="18" charset="0"/>
+                            </a:rPr>
+                            <m:t>,</m:t>
+                          </m:r>
+                          <m:acc>
+                            <m:accPr>
+                              <m:chr m:val="̇"/>
+                              <m:ctrlPr>
+                                <a:rPr lang="en-US" sz="900" b="0" i="1" smtClean="0">
+                                  <a:solidFill>
+                                    <a:schemeClr val="tx1"/>
+                                  </a:solidFill>
+                                  <a:latin typeface="Cambria Math" panose="02040503050406030204" pitchFamily="18" charset="0"/>
+                                  <a:ea typeface="Cambria Math" panose="02040503050406030204" pitchFamily="18" charset="0"/>
+                                </a:rPr>
+                              </m:ctrlPr>
+                            </m:accPr>
+                            <m:e>
+                              <m:r>
+                                <a:rPr lang="en-US" sz="900" b="0" i="1" smtClean="0">
+                                  <a:solidFill>
+                                    <a:schemeClr val="tx1"/>
+                                  </a:solidFill>
+                                  <a:latin typeface="Cambria Math" panose="02040503050406030204" pitchFamily="18" charset="0"/>
+                                  <a:ea typeface="Cambria Math" panose="02040503050406030204" pitchFamily="18" charset="0"/>
+                                </a:rPr>
+                                <m:t>𝑞</m:t>
+                              </m:r>
+                            </m:e>
+                          </m:acc>
+                        </m:e>
+                      </m:d>
+                      <m:r>
+                        <a:rPr lang="en-US" sz="900" b="0" i="1" smtClean="0">
+                          <a:solidFill>
+                            <a:schemeClr val="tx1"/>
+                          </a:solidFill>
+                          <a:latin typeface="Cambria Math" panose="02040503050406030204" pitchFamily="18" charset="0"/>
+                          <a:ea typeface="Cambria Math" panose="02040503050406030204" pitchFamily="18" charset="0"/>
+                        </a:rPr>
+                        <m:t>+</m:t>
+                      </m:r>
+                      <m:r>
+                        <a:rPr lang="en-US" sz="900" b="0" i="1" smtClean="0">
+                          <a:solidFill>
+                            <a:schemeClr val="tx1"/>
+                          </a:solidFill>
+                          <a:latin typeface="Cambria Math" panose="02040503050406030204" pitchFamily="18" charset="0"/>
+                          <a:ea typeface="Cambria Math" panose="02040503050406030204" pitchFamily="18" charset="0"/>
+                        </a:rPr>
+                        <m:t>𝑉</m:t>
+                      </m:r>
+                      <m:d>
+                        <m:dPr>
+                          <m:ctrlPr>
+                            <a:rPr lang="en-US" sz="900" b="0" i="1" smtClean="0">
+                              <a:solidFill>
+                                <a:schemeClr val="tx1"/>
+                              </a:solidFill>
+                              <a:latin typeface="Cambria Math" panose="02040503050406030204" pitchFamily="18" charset="0"/>
+                              <a:ea typeface="Cambria Math" panose="02040503050406030204" pitchFamily="18" charset="0"/>
+                            </a:rPr>
+                          </m:ctrlPr>
+                        </m:dPr>
+                        <m:e>
+                          <m:r>
+                            <a:rPr lang="en-US" sz="900" b="0" i="1" smtClean="0">
+                              <a:solidFill>
+                                <a:schemeClr val="tx1"/>
+                              </a:solidFill>
+                              <a:latin typeface="Cambria Math" panose="02040503050406030204" pitchFamily="18" charset="0"/>
+                              <a:ea typeface="Cambria Math" panose="02040503050406030204" pitchFamily="18" charset="0"/>
+                            </a:rPr>
+                            <m:t>𝑞</m:t>
+                          </m:r>
+                        </m:e>
+                      </m:d>
+                      <m:r>
+                        <a:rPr lang="en-US" sz="900" b="0" i="1" smtClean="0">
+                          <a:solidFill>
+                            <a:schemeClr val="tx1"/>
+                          </a:solidFill>
+                          <a:latin typeface="Cambria Math" panose="02040503050406030204" pitchFamily="18" charset="0"/>
+                          <a:ea typeface="Cambria Math" panose="02040503050406030204" pitchFamily="18" charset="0"/>
+                        </a:rPr>
+                        <m:t>=</m:t>
+                      </m:r>
+                      <m:r>
+                        <a:rPr lang="en-US" sz="900" b="0" i="1" smtClean="0">
+                          <a:solidFill>
+                            <a:schemeClr val="tx1"/>
+                          </a:solidFill>
+                          <a:latin typeface="Cambria Math" panose="02040503050406030204" pitchFamily="18" charset="0"/>
+                          <a:ea typeface="Cambria Math" panose="02040503050406030204" pitchFamily="18" charset="0"/>
+                        </a:rPr>
+                        <m:t>𝐸</m:t>
+                      </m:r>
+                    </m:oMath>
+                  </m:oMathPara>
+                </a14:m>
+                <a:endParaRPr lang="en-US" sz="900" dirty="0">
+                  <a:solidFill>
+                    <a:schemeClr val="tx1"/>
+                  </a:solidFill>
+                </a:endParaRPr>
+              </a:p>
+              <a:p>
+                <a:pPr algn="ctr"/>
+                <a:r>
+                  <a:rPr lang="en-US" sz="900" dirty="0">
+                    <a:solidFill>
+                      <a:schemeClr val="tx1"/>
+                    </a:solidFill>
+                  </a:rPr>
+                  <a:t>Accessible region: </a:t>
+                </a:r>
+                <a14:m>
+                  <m:oMath xmlns:m="http://schemas.openxmlformats.org/officeDocument/2006/math">
+                    <m:r>
+                      <a:rPr lang="en-US" sz="900" b="0" i="1" smtClean="0">
+                        <a:solidFill>
+                          <a:schemeClr val="tx1"/>
+                        </a:solidFill>
+                        <a:latin typeface="Cambria Math" panose="02040503050406030204" pitchFamily="18" charset="0"/>
+                        <a:ea typeface="Cambria Math" panose="02040503050406030204" pitchFamily="18" charset="0"/>
+                      </a:rPr>
+                      <m:t>𝑉</m:t>
+                    </m:r>
+                    <m:d>
+                      <m:dPr>
+                        <m:ctrlPr>
+                          <a:rPr lang="en-US" sz="900" b="0" i="1" smtClean="0">
+                            <a:solidFill>
+                              <a:schemeClr val="tx1"/>
+                            </a:solidFill>
+                            <a:latin typeface="Cambria Math" panose="02040503050406030204" pitchFamily="18" charset="0"/>
+                            <a:ea typeface="Cambria Math" panose="02040503050406030204" pitchFamily="18" charset="0"/>
+                          </a:rPr>
+                        </m:ctrlPr>
+                      </m:dPr>
+                      <m:e>
+                        <m:r>
+                          <a:rPr lang="en-US" sz="900" b="0" i="1" smtClean="0">
+                            <a:solidFill>
+                              <a:schemeClr val="tx1"/>
+                            </a:solidFill>
+                            <a:latin typeface="Cambria Math" panose="02040503050406030204" pitchFamily="18" charset="0"/>
+                            <a:ea typeface="Cambria Math" panose="02040503050406030204" pitchFamily="18" charset="0"/>
+                          </a:rPr>
+                          <m:t>𝑞</m:t>
+                        </m:r>
+                      </m:e>
+                    </m:d>
+                    <m:r>
+                      <a:rPr lang="en-US" sz="900" b="0" i="1" smtClean="0">
+                        <a:solidFill>
+                          <a:schemeClr val="tx1"/>
+                        </a:solidFill>
+                        <a:latin typeface="Cambria Math" panose="02040503050406030204" pitchFamily="18" charset="0"/>
+                        <a:ea typeface="Cambria Math" panose="02040503050406030204" pitchFamily="18" charset="0"/>
+                      </a:rPr>
+                      <m:t>&lt;</m:t>
+                    </m:r>
+                    <m:r>
+                      <a:rPr lang="en-US" sz="900" b="0" i="1" smtClean="0">
+                        <a:solidFill>
+                          <a:schemeClr val="tx1"/>
+                        </a:solidFill>
+                        <a:latin typeface="Cambria Math" panose="02040503050406030204" pitchFamily="18" charset="0"/>
+                        <a:ea typeface="Cambria Math" panose="02040503050406030204" pitchFamily="18" charset="0"/>
+                      </a:rPr>
+                      <m:t>𝐸</m:t>
+                    </m:r>
+                  </m:oMath>
+                </a14:m>
+                <a:endParaRPr lang="en-US" sz="900" dirty="0">
+                  <a:solidFill>
+                    <a:schemeClr val="tx1"/>
+                  </a:solidFill>
+                </a:endParaRPr>
+              </a:p>
+            </p:txBody>
+          </p:sp>
+        </mc:Choice>
+        <mc:Fallback>
+          <p:sp>
+            <p:nvSpPr>
+              <p:cNvPr id="5" name="Rounded Rectangle 4">
+                <a:extLst>
+                  <a:ext uri="{FF2B5EF4-FFF2-40B4-BE49-F238E27FC236}">
+                    <a16:creationId xmlns:a16="http://schemas.microsoft.com/office/drawing/2014/main" id="{2EF0B5C9-B2FD-4957-5E8C-9A5AFBF2EF3A}"/>
+                  </a:ext>
+                </a:extLst>
+              </p:cNvPr>
+              <p:cNvSpPr>
+                <a:spLocks noRot="1" noChangeAspect="1" noMove="1" noResize="1" noEditPoints="1" noAdjustHandles="1" noChangeArrowheads="1" noChangeShapeType="1" noTextEdit="1"/>
+              </p:cNvSpPr>
+              <p:nvPr/>
+            </p:nvSpPr>
+            <p:spPr>
+              <a:xfrm>
+                <a:off x="3191774" y="2013034"/>
+                <a:ext cx="2719458" cy="647897"/>
+              </a:xfrm>
+              <a:prstGeom prst="roundRect">
+                <a:avLst/>
+              </a:prstGeom>
+              <a:blipFill>
+                <a:blip r:embed="rId3"/>
+                <a:stretch>
+                  <a:fillRect/>
+                </a:stretch>
+              </a:blipFill>
+            </p:spPr>
+            <p:txBody>
+              <a:bodyPr/>
+              <a:lstStyle/>
+              <a:p>
+                <a:r>
+                  <a:rPr lang="en-US">
+                    <a:noFill/>
+                  </a:rPr>
+                  <a:t> </a:t>
+                </a:r>
+              </a:p>
+            </p:txBody>
+          </p:sp>
+        </mc:Fallback>
+      </mc:AlternateContent>
     </p:spTree>
     <p:extLst>
       <p:ext uri="{BB962C8B-B14F-4D97-AF65-F5344CB8AC3E}">

</xml_diff>

<commit_message>
update paper v4 and pptx
</commit_message>
<xml_diff>
--- a/docs/Riemannian_geodesics/Figures_for_Jacobi_metric_and_Riemannian_geometry.pptx
+++ b/docs/Riemannian_geodesics/Figures_for_Jacobi_metric_and_Riemannian_geometry.pptx
@@ -4210,6 +4210,283 @@
           </p:sp>
         </mc:Fallback>
       </mc:AlternateContent>
+      <mc:AlternateContent xmlns:mc="http://schemas.openxmlformats.org/markup-compatibility/2006">
+        <mc:Choice xmlns:a14="http://schemas.microsoft.com/office/drawing/2010/main" Requires="a14">
+          <p:sp>
+            <p:nvSpPr>
+              <p:cNvPr id="6" name="Rounded Rectangle 5">
+                <a:extLst>
+                  <a:ext uri="{FF2B5EF4-FFF2-40B4-BE49-F238E27FC236}">
+                    <a16:creationId xmlns:a16="http://schemas.microsoft.com/office/drawing/2014/main" id="{43469090-12FC-DD42-7B06-28D0B213EFAE}"/>
+                  </a:ext>
+                </a:extLst>
+              </p:cNvPr>
+              <p:cNvSpPr/>
+              <p:nvPr/>
+            </p:nvSpPr>
+            <p:spPr>
+              <a:xfrm>
+                <a:off x="3191774" y="3152662"/>
+                <a:ext cx="2719458" cy="647897"/>
+              </a:xfrm>
+              <a:prstGeom prst="roundRect">
+                <a:avLst/>
+              </a:prstGeom>
+              <a:solidFill>
+                <a:srgbClr val="92D050">
+                  <a:alpha val="25882"/>
+                </a:srgbClr>
+              </a:solidFill>
+            </p:spPr>
+            <p:style>
+              <a:lnRef idx="2">
+                <a:schemeClr val="accent1">
+                  <a:shade val="15000"/>
+                </a:schemeClr>
+              </a:lnRef>
+              <a:fillRef idx="1">
+                <a:schemeClr val="accent1"/>
+              </a:fillRef>
+              <a:effectRef idx="0">
+                <a:schemeClr val="accent1"/>
+              </a:effectRef>
+              <a:fontRef idx="minor">
+                <a:schemeClr val="lt1"/>
+              </a:fontRef>
+            </p:style>
+            <p:txBody>
+              <a:bodyPr rtlCol="0" anchor="ctr"/>
+              <a:lstStyle/>
+              <a:p>
+                <a:pPr algn="ctr"/>
+                <a:r>
+                  <a:rPr lang="en-US" sz="900" dirty="0">
+                    <a:solidFill>
+                      <a:schemeClr val="tx1"/>
+                    </a:solidFill>
+                  </a:rPr>
+                  <a:t>Maupertuis principle</a:t>
+                </a:r>
+              </a:p>
+              <a:p>
+                <a:pPr algn="ctr"/>
+                <a14:m>
+                  <m:oMathPara xmlns:m="http://schemas.openxmlformats.org/officeDocument/2006/math">
+                    <m:oMathParaPr>
+                      <m:jc m:val="centerGroup"/>
+                    </m:oMathParaPr>
+                    <m:oMath xmlns:m="http://schemas.openxmlformats.org/officeDocument/2006/math">
+                      <m:r>
+                        <a:rPr lang="en-US" sz="900" i="1" smtClean="0">
+                          <a:solidFill>
+                            <a:schemeClr val="tx1"/>
+                          </a:solidFill>
+                          <a:latin typeface="Cambria Math" panose="02040503050406030204" pitchFamily="18" charset="0"/>
+                          <a:ea typeface="Cambria Math" panose="02040503050406030204" pitchFamily="18" charset="0"/>
+                        </a:rPr>
+                        <m:t>𝛿</m:t>
+                      </m:r>
+                      <m:r>
+                        <a:rPr lang="en-US" sz="900" b="0" i="1" smtClean="0">
+                          <a:solidFill>
+                            <a:schemeClr val="tx1"/>
+                          </a:solidFill>
+                          <a:latin typeface="Cambria Math" panose="02040503050406030204" pitchFamily="18" charset="0"/>
+                          <a:ea typeface="Cambria Math" panose="02040503050406030204" pitchFamily="18" charset="0"/>
+                        </a:rPr>
+                        <m:t>𝑊</m:t>
+                      </m:r>
+                      <m:r>
+                        <a:rPr lang="en-US" sz="900" b="0" i="1" smtClean="0">
+                          <a:solidFill>
+                            <a:schemeClr val="tx1"/>
+                          </a:solidFill>
+                          <a:latin typeface="Cambria Math" panose="02040503050406030204" pitchFamily="18" charset="0"/>
+                          <a:ea typeface="Cambria Math" panose="02040503050406030204" pitchFamily="18" charset="0"/>
+                        </a:rPr>
+                        <m:t>=</m:t>
+                      </m:r>
+                      <m:r>
+                        <a:rPr lang="en-US" sz="900" b="0" i="1" smtClean="0">
+                          <a:solidFill>
+                            <a:schemeClr val="tx1"/>
+                          </a:solidFill>
+                          <a:latin typeface="Cambria Math" panose="02040503050406030204" pitchFamily="18" charset="0"/>
+                          <a:ea typeface="Cambria Math" panose="02040503050406030204" pitchFamily="18" charset="0"/>
+                        </a:rPr>
+                        <m:t>𝛿</m:t>
+                      </m:r>
+                      <m:nary>
+                        <m:naryPr>
+                          <m:limLoc m:val="undOvr"/>
+                          <m:subHide m:val="on"/>
+                          <m:supHide m:val="on"/>
+                          <m:ctrlPr>
+                            <a:rPr lang="en-US" sz="900" b="0" i="1" smtClean="0">
+                              <a:solidFill>
+                                <a:schemeClr val="tx1"/>
+                              </a:solidFill>
+                              <a:latin typeface="Cambria Math" panose="02040503050406030204" pitchFamily="18" charset="0"/>
+                              <a:ea typeface="Cambria Math" panose="02040503050406030204" pitchFamily="18" charset="0"/>
+                            </a:rPr>
+                          </m:ctrlPr>
+                        </m:naryPr>
+                        <m:sub/>
+                        <m:sup/>
+                        <m:e>
+                          <m:sSub>
+                            <m:sSubPr>
+                              <m:ctrlPr>
+                                <a:rPr lang="en-US" sz="900" b="0" i="1" smtClean="0">
+                                  <a:solidFill>
+                                    <a:schemeClr val="tx1"/>
+                                  </a:solidFill>
+                                  <a:latin typeface="Cambria Math" panose="02040503050406030204" pitchFamily="18" charset="0"/>
+                                  <a:ea typeface="Cambria Math" panose="02040503050406030204" pitchFamily="18" charset="0"/>
+                                </a:rPr>
+                              </m:ctrlPr>
+                            </m:sSubPr>
+                            <m:e>
+                              <m:r>
+                                <a:rPr lang="en-US" sz="900" b="0" i="1" smtClean="0">
+                                  <a:solidFill>
+                                    <a:schemeClr val="tx1"/>
+                                  </a:solidFill>
+                                  <a:latin typeface="Cambria Math" panose="02040503050406030204" pitchFamily="18" charset="0"/>
+                                  <a:ea typeface="Cambria Math" panose="02040503050406030204" pitchFamily="18" charset="0"/>
+                                </a:rPr>
+                                <m:t>𝑝</m:t>
+                              </m:r>
+                            </m:e>
+                            <m:sub>
+                              <m:r>
+                                <a:rPr lang="en-US" sz="900" b="0" i="1" smtClean="0">
+                                  <a:solidFill>
+                                    <a:schemeClr val="tx1"/>
+                                  </a:solidFill>
+                                  <a:latin typeface="Cambria Math" panose="02040503050406030204" pitchFamily="18" charset="0"/>
+                                  <a:ea typeface="Cambria Math" panose="02040503050406030204" pitchFamily="18" charset="0"/>
+                                </a:rPr>
+                                <m:t>𝑖</m:t>
+                              </m:r>
+                            </m:sub>
+                          </m:sSub>
+                          <m:r>
+                            <a:rPr lang="en-US" sz="900" b="0" i="1" smtClean="0">
+                              <a:solidFill>
+                                <a:schemeClr val="tx1"/>
+                              </a:solidFill>
+                              <a:latin typeface="Cambria Math" panose="02040503050406030204" pitchFamily="18" charset="0"/>
+                              <a:ea typeface="Cambria Math" panose="02040503050406030204" pitchFamily="18" charset="0"/>
+                            </a:rPr>
+                            <m:t>𝑑</m:t>
+                          </m:r>
+                          <m:sSup>
+                            <m:sSupPr>
+                              <m:ctrlPr>
+                                <a:rPr lang="en-US" sz="900" b="0" i="1" smtClean="0">
+                                  <a:solidFill>
+                                    <a:schemeClr val="tx1"/>
+                                  </a:solidFill>
+                                  <a:latin typeface="Cambria Math" panose="02040503050406030204" pitchFamily="18" charset="0"/>
+                                  <a:ea typeface="Cambria Math" panose="02040503050406030204" pitchFamily="18" charset="0"/>
+                                </a:rPr>
+                              </m:ctrlPr>
+                            </m:sSupPr>
+                            <m:e>
+                              <m:r>
+                                <a:rPr lang="en-US" sz="900" b="0" i="1" smtClean="0">
+                                  <a:solidFill>
+                                    <a:schemeClr val="tx1"/>
+                                  </a:solidFill>
+                                  <a:latin typeface="Cambria Math" panose="02040503050406030204" pitchFamily="18" charset="0"/>
+                                  <a:ea typeface="Cambria Math" panose="02040503050406030204" pitchFamily="18" charset="0"/>
+                                </a:rPr>
+                                <m:t>𝑞</m:t>
+                              </m:r>
+                            </m:e>
+                            <m:sup>
+                              <m:r>
+                                <a:rPr lang="en-US" sz="900" b="0" i="1" smtClean="0">
+                                  <a:solidFill>
+                                    <a:schemeClr val="tx1"/>
+                                  </a:solidFill>
+                                  <a:latin typeface="Cambria Math" panose="02040503050406030204" pitchFamily="18" charset="0"/>
+                                  <a:ea typeface="Cambria Math" panose="02040503050406030204" pitchFamily="18" charset="0"/>
+                                </a:rPr>
+                                <m:t>𝑖</m:t>
+                              </m:r>
+                            </m:sup>
+                          </m:sSup>
+                          <m:r>
+                            <a:rPr lang="en-US" sz="900" b="0" i="1" smtClean="0">
+                              <a:solidFill>
+                                <a:schemeClr val="tx1"/>
+                              </a:solidFill>
+                              <a:latin typeface="Cambria Math" panose="02040503050406030204" pitchFamily="18" charset="0"/>
+                              <a:ea typeface="Cambria Math" panose="02040503050406030204" pitchFamily="18" charset="0"/>
+                            </a:rPr>
+                            <m:t>=</m:t>
+                          </m:r>
+                        </m:e>
+                      </m:nary>
+                    </m:oMath>
+                  </m:oMathPara>
+                </a14:m>
+                <a:endParaRPr lang="en-US" sz="900" dirty="0">
+                  <a:solidFill>
+                    <a:schemeClr val="tx1"/>
+                  </a:solidFill>
+                </a:endParaRPr>
+              </a:p>
+            </p:txBody>
+          </p:sp>
+        </mc:Choice>
+        <mc:Fallback>
+          <p:sp>
+            <p:nvSpPr>
+              <p:cNvPr id="6" name="Rounded Rectangle 5">
+                <a:extLst>
+                  <a:ext uri="{FF2B5EF4-FFF2-40B4-BE49-F238E27FC236}">
+                    <a16:creationId xmlns:a16="http://schemas.microsoft.com/office/drawing/2014/main" id="{43469090-12FC-DD42-7B06-28D0B213EFAE}"/>
+                  </a:ext>
+                </a:extLst>
+              </p:cNvPr>
+              <p:cNvSpPr>
+                <a:spLocks noRot="1" noChangeAspect="1" noMove="1" noResize="1" noEditPoints="1" noAdjustHandles="1" noChangeArrowheads="1" noChangeShapeType="1" noTextEdit="1"/>
+              </p:cNvSpPr>
+              <p:nvPr/>
+            </p:nvSpPr>
+            <p:spPr>
+              <a:xfrm>
+                <a:off x="3191774" y="3152662"/>
+                <a:ext cx="2719458" cy="647897"/>
+              </a:xfrm>
+              <a:prstGeom prst="roundRect">
+                <a:avLst/>
+              </a:prstGeom>
+              <a:blipFill>
+                <a:blip r:embed="rId4"/>
+                <a:stretch>
+                  <a:fillRect t="-49057" b="-105660"/>
+                </a:stretch>
+              </a:blipFill>
+            </p:spPr>
+            <p:txBody>
+              <a:bodyPr/>
+              <a:lstStyle/>
+              <a:p>
+                <a:r>
+                  <a:rPr lang="en-US">
+                    <a:noFill/>
+                  </a:rPr>
+                  <a:t> </a:t>
+                </a:r>
+              </a:p>
+            </p:txBody>
+          </p:sp>
+        </mc:Fallback>
+      </mc:AlternateContent>
     </p:spTree>
     <p:extLst>
       <p:ext uri="{BB962C8B-B14F-4D97-AF65-F5344CB8AC3E}">

</xml_diff>

<commit_message>
update Riemannian geodesics docx and figures
</commit_message>
<xml_diff>
--- a/docs/Riemannian_geodesics/Figures_for_Jacobi_metric_and_Riemannian_geometry.pptx
+++ b/docs/Riemannian_geodesics/Figures_for_Jacobi_metric_and_Riemannian_geometry.pptx
@@ -104,6 +104,11 @@
       </a:defRPr>
     </a:lvl9pPr>
   </p:defaultTextStyle>
+  <p:extLst>
+    <p:ext uri="{EFAFB233-063F-42B5-8137-9DF3F51BA10A}">
+      <p15:sldGuideLst xmlns:p15="http://schemas.microsoft.com/office/powerpoint/2012/main"/>
+    </p:ext>
+  </p:extLst>
 </p:presentation>
 </file>
 
@@ -254,7 +259,7 @@
           <a:p>
             <a:fld id="{BE5B20FD-4676-7544-B6B1-AA9D583F04F4}" type="datetimeFigureOut">
               <a:rPr lang="en-US" smtClean="0"/>
-              <a:t>6/10/26</a:t>
+              <a:t>8/16/26</a:t>
             </a:fld>
             <a:endParaRPr lang="en-US"/>
           </a:p>
@@ -452,7 +457,7 @@
           <a:p>
             <a:fld id="{BE5B20FD-4676-7544-B6B1-AA9D583F04F4}" type="datetimeFigureOut">
               <a:rPr lang="en-US" smtClean="0"/>
-              <a:t>6/10/26</a:t>
+              <a:t>8/16/26</a:t>
             </a:fld>
             <a:endParaRPr lang="en-US"/>
           </a:p>
@@ -660,7 +665,7 @@
           <a:p>
             <a:fld id="{BE5B20FD-4676-7544-B6B1-AA9D583F04F4}" type="datetimeFigureOut">
               <a:rPr lang="en-US" smtClean="0"/>
-              <a:t>6/10/26</a:t>
+              <a:t>8/16/26</a:t>
             </a:fld>
             <a:endParaRPr lang="en-US"/>
           </a:p>
@@ -858,7 +863,7 @@
           <a:p>
             <a:fld id="{BE5B20FD-4676-7544-B6B1-AA9D583F04F4}" type="datetimeFigureOut">
               <a:rPr lang="en-US" smtClean="0"/>
-              <a:t>6/10/26</a:t>
+              <a:t>8/16/26</a:t>
             </a:fld>
             <a:endParaRPr lang="en-US"/>
           </a:p>
@@ -1133,7 +1138,7 @@
           <a:p>
             <a:fld id="{BE5B20FD-4676-7544-B6B1-AA9D583F04F4}" type="datetimeFigureOut">
               <a:rPr lang="en-US" smtClean="0"/>
-              <a:t>6/10/26</a:t>
+              <a:t>8/16/26</a:t>
             </a:fld>
             <a:endParaRPr lang="en-US"/>
           </a:p>
@@ -1398,7 +1403,7 @@
           <a:p>
             <a:fld id="{BE5B20FD-4676-7544-B6B1-AA9D583F04F4}" type="datetimeFigureOut">
               <a:rPr lang="en-US" smtClean="0"/>
-              <a:t>6/10/26</a:t>
+              <a:t>8/16/26</a:t>
             </a:fld>
             <a:endParaRPr lang="en-US"/>
           </a:p>
@@ -1810,7 +1815,7 @@
           <a:p>
             <a:fld id="{BE5B20FD-4676-7544-B6B1-AA9D583F04F4}" type="datetimeFigureOut">
               <a:rPr lang="en-US" smtClean="0"/>
-              <a:t>6/10/26</a:t>
+              <a:t>8/16/26</a:t>
             </a:fld>
             <a:endParaRPr lang="en-US"/>
           </a:p>
@@ -1951,7 +1956,7 @@
           <a:p>
             <a:fld id="{BE5B20FD-4676-7544-B6B1-AA9D583F04F4}" type="datetimeFigureOut">
               <a:rPr lang="en-US" smtClean="0"/>
-              <a:t>6/10/26</a:t>
+              <a:t>8/16/26</a:t>
             </a:fld>
             <a:endParaRPr lang="en-US"/>
           </a:p>
@@ -2064,7 +2069,7 @@
           <a:p>
             <a:fld id="{BE5B20FD-4676-7544-B6B1-AA9D583F04F4}" type="datetimeFigureOut">
               <a:rPr lang="en-US" smtClean="0"/>
-              <a:t>6/10/26</a:t>
+              <a:t>8/16/26</a:t>
             </a:fld>
             <a:endParaRPr lang="en-US"/>
           </a:p>
@@ -2375,7 +2380,7 @@
           <a:p>
             <a:fld id="{BE5B20FD-4676-7544-B6B1-AA9D583F04F4}" type="datetimeFigureOut">
               <a:rPr lang="en-US" smtClean="0"/>
-              <a:t>6/10/26</a:t>
+              <a:t>8/16/26</a:t>
             </a:fld>
             <a:endParaRPr lang="en-US"/>
           </a:p>
@@ -2663,7 +2668,7 @@
           <a:p>
             <a:fld id="{BE5B20FD-4676-7544-B6B1-AA9D583F04F4}" type="datetimeFigureOut">
               <a:rPr lang="en-US" smtClean="0"/>
-              <a:t>6/10/26</a:t>
+              <a:t>8/16/26</a:t>
             </a:fld>
             <a:endParaRPr lang="en-US"/>
           </a:p>
@@ -2904,7 +2909,7 @@
           <a:p>
             <a:fld id="{BE5B20FD-4676-7544-B6B1-AA9D583F04F4}" type="datetimeFigureOut">
               <a:rPr lang="en-US" smtClean="0"/>
-              <a:t>6/10/26</a:t>
+              <a:t>8/16/26</a:t>
             </a:fld>
             <a:endParaRPr lang="en-US"/>
           </a:p>
@@ -3321,8 +3326,8 @@
           <a:chExt cx="0" cy="0"/>
         </a:xfrm>
       </p:grpSpPr>
-      <mc:AlternateContent xmlns:mc="http://schemas.openxmlformats.org/markup-compatibility/2006">
-        <mc:Choice xmlns:a14="http://schemas.microsoft.com/office/drawing/2010/main" Requires="a14">
+      <mc:AlternateContent xmlns:mc="http://schemas.openxmlformats.org/markup-compatibility/2006" xmlns:a14="http://schemas.microsoft.com/office/drawing/2010/main">
+        <mc:Choice Requires="a14">
           <p:sp>
             <p:nvSpPr>
               <p:cNvPr id="4" name="Rounded Rectangle 3">
@@ -3831,7 +3836,7 @@
             </p:txBody>
           </p:sp>
         </mc:Choice>
-        <mc:Fallback>
+        <mc:Fallback xmlns="">
           <p:sp>
             <p:nvSpPr>
               <p:cNvPr id="4" name="Rounded Rectangle 3">
@@ -3876,8 +3881,8 @@
           </p:sp>
         </mc:Fallback>
       </mc:AlternateContent>
-      <mc:AlternateContent xmlns:mc="http://schemas.openxmlformats.org/markup-compatibility/2006">
-        <mc:Choice xmlns:a14="http://schemas.microsoft.com/office/drawing/2010/main" Requires="a14">
+      <mc:AlternateContent xmlns:mc="http://schemas.openxmlformats.org/markup-compatibility/2006" xmlns:a14="http://schemas.microsoft.com/office/drawing/2010/main">
+        <mc:Choice Requires="a14">
           <p:sp>
             <p:nvSpPr>
               <p:cNvPr id="5" name="Rounded Rectangle 4">
@@ -4165,7 +4170,7 @@
             </p:txBody>
           </p:sp>
         </mc:Choice>
-        <mc:Fallback>
+        <mc:Fallback xmlns="">
           <p:sp>
             <p:nvSpPr>
               <p:cNvPr id="5" name="Rounded Rectangle 4">
@@ -4271,173 +4276,262 @@
               <a:p>
                 <a:pPr algn="ctr"/>
                 <a14:m>
-                  <m:oMathPara xmlns:m="http://schemas.openxmlformats.org/officeDocument/2006/math">
-                    <m:oMathParaPr>
-                      <m:jc m:val="centerGroup"/>
-                    </m:oMathParaPr>
-                    <m:oMath xmlns:m="http://schemas.openxmlformats.org/officeDocument/2006/math">
-                      <m:r>
-                        <a:rPr lang="en-US" sz="900" i="1" smtClean="0">
-                          <a:solidFill>
-                            <a:schemeClr val="tx1"/>
-                          </a:solidFill>
-                          <a:latin typeface="Cambria Math" panose="02040503050406030204" pitchFamily="18" charset="0"/>
-                          <a:ea typeface="Cambria Math" panose="02040503050406030204" pitchFamily="18" charset="0"/>
-                        </a:rPr>
-                        <m:t>𝛿</m:t>
-                      </m:r>
-                      <m:r>
-                        <a:rPr lang="en-US" sz="900" b="0" i="1" smtClean="0">
-                          <a:solidFill>
-                            <a:schemeClr val="tx1"/>
-                          </a:solidFill>
-                          <a:latin typeface="Cambria Math" panose="02040503050406030204" pitchFamily="18" charset="0"/>
-                          <a:ea typeface="Cambria Math" panose="02040503050406030204" pitchFamily="18" charset="0"/>
-                        </a:rPr>
-                        <m:t>𝑊</m:t>
-                      </m:r>
-                      <m:r>
-                        <a:rPr lang="en-US" sz="900" b="0" i="1" smtClean="0">
-                          <a:solidFill>
-                            <a:schemeClr val="tx1"/>
-                          </a:solidFill>
-                          <a:latin typeface="Cambria Math" panose="02040503050406030204" pitchFamily="18" charset="0"/>
-                          <a:ea typeface="Cambria Math" panose="02040503050406030204" pitchFamily="18" charset="0"/>
-                        </a:rPr>
-                        <m:t>=</m:t>
-                      </m:r>
-                      <m:r>
-                        <a:rPr lang="en-US" sz="900" b="0" i="1" smtClean="0">
-                          <a:solidFill>
-                            <a:schemeClr val="tx1"/>
-                          </a:solidFill>
-                          <a:latin typeface="Cambria Math" panose="02040503050406030204" pitchFamily="18" charset="0"/>
-                          <a:ea typeface="Cambria Math" panose="02040503050406030204" pitchFamily="18" charset="0"/>
-                        </a:rPr>
-                        <m:t>𝛿</m:t>
-                      </m:r>
-                      <m:nary>
-                        <m:naryPr>
-                          <m:limLoc m:val="undOvr"/>
-                          <m:subHide m:val="on"/>
-                          <m:supHide m:val="on"/>
-                          <m:ctrlPr>
-                            <a:rPr lang="en-US" sz="900" b="0" i="1" smtClean="0">
-                              <a:solidFill>
-                                <a:schemeClr val="tx1"/>
-                              </a:solidFill>
-                              <a:latin typeface="Cambria Math" panose="02040503050406030204" pitchFamily="18" charset="0"/>
-                              <a:ea typeface="Cambria Math" panose="02040503050406030204" pitchFamily="18" charset="0"/>
-                            </a:rPr>
-                          </m:ctrlPr>
-                        </m:naryPr>
-                        <m:sub/>
-                        <m:sup/>
-                        <m:e>
-                          <m:sSub>
-                            <m:sSubPr>
-                              <m:ctrlPr>
-                                <a:rPr lang="en-US" sz="900" b="0" i="1" smtClean="0">
-                                  <a:solidFill>
-                                    <a:schemeClr val="tx1"/>
-                                  </a:solidFill>
-                                  <a:latin typeface="Cambria Math" panose="02040503050406030204" pitchFamily="18" charset="0"/>
-                                  <a:ea typeface="Cambria Math" panose="02040503050406030204" pitchFamily="18" charset="0"/>
-                                </a:rPr>
-                              </m:ctrlPr>
-                            </m:sSubPr>
-                            <m:e>
-                              <m:r>
-                                <a:rPr lang="en-US" sz="900" b="0" i="1" smtClean="0">
-                                  <a:solidFill>
-                                    <a:schemeClr val="tx1"/>
-                                  </a:solidFill>
-                                  <a:latin typeface="Cambria Math" panose="02040503050406030204" pitchFamily="18" charset="0"/>
-                                  <a:ea typeface="Cambria Math" panose="02040503050406030204" pitchFamily="18" charset="0"/>
-                                </a:rPr>
-                                <m:t>𝑝</m:t>
-                              </m:r>
-                            </m:e>
-                            <m:sub>
-                              <m:r>
-                                <a:rPr lang="en-US" sz="900" b="0" i="1" smtClean="0">
-                                  <a:solidFill>
-                                    <a:schemeClr val="tx1"/>
-                                  </a:solidFill>
-                                  <a:latin typeface="Cambria Math" panose="02040503050406030204" pitchFamily="18" charset="0"/>
-                                  <a:ea typeface="Cambria Math" panose="02040503050406030204" pitchFamily="18" charset="0"/>
-                                </a:rPr>
-                                <m:t>𝑖</m:t>
-                              </m:r>
-                            </m:sub>
-                          </m:sSub>
-                          <m:r>
-                            <a:rPr lang="en-US" sz="900" b="0" i="1" smtClean="0">
-                              <a:solidFill>
-                                <a:schemeClr val="tx1"/>
-                              </a:solidFill>
-                              <a:latin typeface="Cambria Math" panose="02040503050406030204" pitchFamily="18" charset="0"/>
-                              <a:ea typeface="Cambria Math" panose="02040503050406030204" pitchFamily="18" charset="0"/>
-                            </a:rPr>
-                            <m:t>𝑑</m:t>
-                          </m:r>
-                          <m:sSup>
-                            <m:sSupPr>
-                              <m:ctrlPr>
-                                <a:rPr lang="en-US" sz="900" b="0" i="1" smtClean="0">
-                                  <a:solidFill>
-                                    <a:schemeClr val="tx1"/>
-                                  </a:solidFill>
-                                  <a:latin typeface="Cambria Math" panose="02040503050406030204" pitchFamily="18" charset="0"/>
-                                  <a:ea typeface="Cambria Math" panose="02040503050406030204" pitchFamily="18" charset="0"/>
-                                </a:rPr>
-                              </m:ctrlPr>
-                            </m:sSupPr>
-                            <m:e>
-                              <m:r>
-                                <a:rPr lang="en-US" sz="900" b="0" i="1" smtClean="0">
-                                  <a:solidFill>
-                                    <a:schemeClr val="tx1"/>
-                                  </a:solidFill>
-                                  <a:latin typeface="Cambria Math" panose="02040503050406030204" pitchFamily="18" charset="0"/>
-                                  <a:ea typeface="Cambria Math" panose="02040503050406030204" pitchFamily="18" charset="0"/>
-                                </a:rPr>
-                                <m:t>𝑞</m:t>
-                              </m:r>
-                            </m:e>
-                            <m:sup>
-                              <m:r>
-                                <a:rPr lang="en-US" sz="900" b="0" i="1" smtClean="0">
-                                  <a:solidFill>
-                                    <a:schemeClr val="tx1"/>
-                                  </a:solidFill>
-                                  <a:latin typeface="Cambria Math" panose="02040503050406030204" pitchFamily="18" charset="0"/>
-                                  <a:ea typeface="Cambria Math" panose="02040503050406030204" pitchFamily="18" charset="0"/>
-                                </a:rPr>
-                                <m:t>𝑖</m:t>
-                              </m:r>
-                            </m:sup>
-                          </m:sSup>
-                          <m:r>
-                            <a:rPr lang="en-US" sz="900" b="0" i="1" smtClean="0">
-                              <a:solidFill>
-                                <a:schemeClr val="tx1"/>
-                              </a:solidFill>
-                              <a:latin typeface="Cambria Math" panose="02040503050406030204" pitchFamily="18" charset="0"/>
-                              <a:ea typeface="Cambria Math" panose="02040503050406030204" pitchFamily="18" charset="0"/>
-                            </a:rPr>
-                            <m:t>=</m:t>
-                          </m:r>
-                        </m:e>
-                      </m:nary>
-                    </m:oMath>
-                  </m:oMathPara>
+                  <m:oMath xmlns:m="http://schemas.openxmlformats.org/officeDocument/2006/math">
+                    <m:r>
+                      <a:rPr lang="en-US" sz="900" i="1" smtClean="0">
+                        <a:solidFill>
+                          <a:schemeClr val="tx1"/>
+                        </a:solidFill>
+                        <a:latin typeface="Cambria Math" panose="02040503050406030204" pitchFamily="18" charset="0"/>
+                        <a:ea typeface="Cambria Math" panose="02040503050406030204" pitchFamily="18" charset="0"/>
+                      </a:rPr>
+                      <m:t>𝛿</m:t>
+                    </m:r>
+                    <m:r>
+                      <a:rPr lang="en-US" sz="900" b="0" i="1" smtClean="0">
+                        <a:solidFill>
+                          <a:schemeClr val="tx1"/>
+                        </a:solidFill>
+                        <a:latin typeface="Cambria Math" panose="02040503050406030204" pitchFamily="18" charset="0"/>
+                        <a:ea typeface="Cambria Math" panose="02040503050406030204" pitchFamily="18" charset="0"/>
+                      </a:rPr>
+                      <m:t>𝑊</m:t>
+                    </m:r>
+                    <m:r>
+                      <a:rPr lang="en-US" sz="900" b="0" i="1" smtClean="0">
+                        <a:solidFill>
+                          <a:schemeClr val="tx1"/>
+                        </a:solidFill>
+                        <a:latin typeface="Cambria Math" panose="02040503050406030204" pitchFamily="18" charset="0"/>
+                        <a:ea typeface="Cambria Math" panose="02040503050406030204" pitchFamily="18" charset="0"/>
+                      </a:rPr>
+                      <m:t>=</m:t>
+                    </m:r>
+                    <m:r>
+                      <a:rPr lang="en-US" sz="900" b="0" i="1" smtClean="0">
+                        <a:solidFill>
+                          <a:schemeClr val="tx1"/>
+                        </a:solidFill>
+                        <a:latin typeface="Cambria Math" panose="02040503050406030204" pitchFamily="18" charset="0"/>
+                        <a:ea typeface="Cambria Math" panose="02040503050406030204" pitchFamily="18" charset="0"/>
+                      </a:rPr>
+                      <m:t>𝛿</m:t>
+                    </m:r>
+                    <m:nary>
+                      <m:naryPr>
+                        <m:limLoc m:val="undOvr"/>
+                        <m:subHide m:val="on"/>
+                        <m:supHide m:val="on"/>
+                        <m:ctrlPr>
+                          <a:rPr lang="en-US" sz="900" b="0" i="1" smtClean="0">
+                            <a:solidFill>
+                              <a:schemeClr val="tx1"/>
+                            </a:solidFill>
+                            <a:latin typeface="Cambria Math" panose="02040503050406030204" pitchFamily="18" charset="0"/>
+                            <a:ea typeface="Cambria Math" panose="02040503050406030204" pitchFamily="18" charset="0"/>
+                          </a:rPr>
+                        </m:ctrlPr>
+                      </m:naryPr>
+                      <m:sub/>
+                      <m:sup/>
+                      <m:e>
+                        <m:sSub>
+                          <m:sSubPr>
+                            <m:ctrlPr>
+                              <a:rPr lang="en-US" sz="900" b="0" i="1" smtClean="0">
+                                <a:solidFill>
+                                  <a:schemeClr val="tx1"/>
+                                </a:solidFill>
+                                <a:latin typeface="Cambria Math" panose="02040503050406030204" pitchFamily="18" charset="0"/>
+                                <a:ea typeface="Cambria Math" panose="02040503050406030204" pitchFamily="18" charset="0"/>
+                              </a:rPr>
+                            </m:ctrlPr>
+                          </m:sSubPr>
+                          <m:e>
+                            <m:r>
+                              <a:rPr lang="en-US" sz="900" b="0" i="1" smtClean="0">
+                                <a:solidFill>
+                                  <a:schemeClr val="tx1"/>
+                                </a:solidFill>
+                                <a:latin typeface="Cambria Math" panose="02040503050406030204" pitchFamily="18" charset="0"/>
+                                <a:ea typeface="Cambria Math" panose="02040503050406030204" pitchFamily="18" charset="0"/>
+                              </a:rPr>
+                              <m:t>𝑝</m:t>
+                            </m:r>
+                          </m:e>
+                          <m:sub>
+                            <m:r>
+                              <a:rPr lang="en-US" sz="900" b="0" i="1" smtClean="0">
+                                <a:solidFill>
+                                  <a:schemeClr val="tx1"/>
+                                </a:solidFill>
+                                <a:latin typeface="Cambria Math" panose="02040503050406030204" pitchFamily="18" charset="0"/>
+                                <a:ea typeface="Cambria Math" panose="02040503050406030204" pitchFamily="18" charset="0"/>
+                              </a:rPr>
+                              <m:t>𝑖</m:t>
+                            </m:r>
+                          </m:sub>
+                        </m:sSub>
+                        <m:r>
+                          <a:rPr lang="en-US" sz="900" b="0" i="1" smtClean="0">
+                            <a:solidFill>
+                              <a:schemeClr val="tx1"/>
+                            </a:solidFill>
+                            <a:latin typeface="Cambria Math" panose="02040503050406030204" pitchFamily="18" charset="0"/>
+                            <a:ea typeface="Cambria Math" panose="02040503050406030204" pitchFamily="18" charset="0"/>
+                          </a:rPr>
+                          <m:t>𝑑</m:t>
+                        </m:r>
+                        <m:sSup>
+                          <m:sSupPr>
+                            <m:ctrlPr>
+                              <a:rPr lang="en-US" sz="900" b="0" i="1" smtClean="0">
+                                <a:solidFill>
+                                  <a:schemeClr val="tx1"/>
+                                </a:solidFill>
+                                <a:latin typeface="Cambria Math" panose="02040503050406030204" pitchFamily="18" charset="0"/>
+                                <a:ea typeface="Cambria Math" panose="02040503050406030204" pitchFamily="18" charset="0"/>
+                              </a:rPr>
+                            </m:ctrlPr>
+                          </m:sSupPr>
+                          <m:e>
+                            <m:r>
+                              <a:rPr lang="en-US" sz="900" b="0" i="1" smtClean="0">
+                                <a:solidFill>
+                                  <a:schemeClr val="tx1"/>
+                                </a:solidFill>
+                                <a:latin typeface="Cambria Math" panose="02040503050406030204" pitchFamily="18" charset="0"/>
+                                <a:ea typeface="Cambria Math" panose="02040503050406030204" pitchFamily="18" charset="0"/>
+                              </a:rPr>
+                              <m:t>𝑞</m:t>
+                            </m:r>
+                          </m:e>
+                          <m:sup>
+                            <m:r>
+                              <a:rPr lang="en-US" sz="900" b="0" i="1" smtClean="0">
+                                <a:solidFill>
+                                  <a:schemeClr val="tx1"/>
+                                </a:solidFill>
+                                <a:latin typeface="Cambria Math" panose="02040503050406030204" pitchFamily="18" charset="0"/>
+                                <a:ea typeface="Cambria Math" panose="02040503050406030204" pitchFamily="18" charset="0"/>
+                              </a:rPr>
+                              <m:t>𝑖</m:t>
+                            </m:r>
+                          </m:sup>
+                        </m:sSup>
+                        <m:r>
+                          <a:rPr lang="en-US" sz="900" b="0" i="1" smtClean="0">
+                            <a:solidFill>
+                              <a:schemeClr val="tx1"/>
+                            </a:solidFill>
+                            <a:latin typeface="Cambria Math" panose="02040503050406030204" pitchFamily="18" charset="0"/>
+                            <a:ea typeface="Cambria Math" panose="02040503050406030204" pitchFamily="18" charset="0"/>
+                          </a:rPr>
+                          <m:t>=</m:t>
+                        </m:r>
+                      </m:e>
+                    </m:nary>
+                    <m:r>
+                      <a:rPr lang="en-US" sz="900" i="1">
+                        <a:solidFill>
+                          <a:schemeClr val="tx1"/>
+                        </a:solidFill>
+                        <a:latin typeface="Cambria Math" panose="02040503050406030204" pitchFamily="18" charset="0"/>
+                        <a:ea typeface="Cambria Math" panose="02040503050406030204" pitchFamily="18" charset="0"/>
+                      </a:rPr>
+                      <m:t>𝛿</m:t>
+                    </m:r>
+                    <m:nary>
+                      <m:naryPr>
+                        <m:limLoc m:val="undOvr"/>
+                        <m:subHide m:val="on"/>
+                        <m:supHide m:val="on"/>
+                        <m:ctrlPr>
+                          <a:rPr lang="en-US" sz="900" i="1">
+                            <a:solidFill>
+                              <a:schemeClr val="tx1"/>
+                            </a:solidFill>
+                            <a:latin typeface="Cambria Math" panose="02040503050406030204" pitchFamily="18" charset="0"/>
+                            <a:ea typeface="Cambria Math" panose="02040503050406030204" pitchFamily="18" charset="0"/>
+                          </a:rPr>
+                        </m:ctrlPr>
+                      </m:naryPr>
+                      <m:sub/>
+                      <m:sup/>
+                      <m:e>
+                        <m:r>
+                          <a:rPr lang="en-US" sz="900" b="0" i="1" smtClean="0">
+                            <a:solidFill>
+                              <a:schemeClr val="tx1"/>
+                            </a:solidFill>
+                            <a:latin typeface="Cambria Math" panose="02040503050406030204" pitchFamily="18" charset="0"/>
+                            <a:ea typeface="Cambria Math" panose="02040503050406030204" pitchFamily="18" charset="0"/>
+                          </a:rPr>
+                          <m:t>2</m:t>
+                        </m:r>
+                        <m:r>
+                          <a:rPr lang="en-US" sz="900" b="0" i="1" smtClean="0">
+                            <a:solidFill>
+                              <a:schemeClr val="tx1"/>
+                            </a:solidFill>
+                            <a:latin typeface="Cambria Math" panose="02040503050406030204" pitchFamily="18" charset="0"/>
+                            <a:ea typeface="Cambria Math" panose="02040503050406030204" pitchFamily="18" charset="0"/>
+                          </a:rPr>
+                          <m:t>𝑇𝑑</m:t>
+                        </m:r>
+                        <m:r>
+                          <a:rPr lang="en-US" sz="900" b="0" i="1" smtClean="0">
+                            <a:solidFill>
+                              <a:schemeClr val="tx1"/>
+                            </a:solidFill>
+                            <a:latin typeface="Cambria Math" panose="02040503050406030204" pitchFamily="18" charset="0"/>
+                            <a:ea typeface="Cambria Math" panose="02040503050406030204" pitchFamily="18" charset="0"/>
+                          </a:rPr>
+                          <m:t>𝑡</m:t>
+                        </m:r>
+                        <m:r>
+                          <a:rPr lang="en-US" sz="900" i="1">
+                            <a:solidFill>
+                              <a:schemeClr val="tx1"/>
+                            </a:solidFill>
+                            <a:latin typeface="Cambria Math" panose="02040503050406030204" pitchFamily="18" charset="0"/>
+                            <a:ea typeface="Cambria Math" panose="02040503050406030204" pitchFamily="18" charset="0"/>
+                          </a:rPr>
+                          <m:t>=</m:t>
+                        </m:r>
+                      </m:e>
+                    </m:nary>
+                  </m:oMath>
                 </a14:m>
-                <a:endParaRPr lang="en-US" sz="900" dirty="0">
-                  <a:solidFill>
-                    <a:schemeClr val="tx1"/>
-                  </a:solidFill>
-                </a:endParaRPr>
+                <a:r>
+                  <a:rPr lang="en-US" sz="900" dirty="0">
+                    <a:solidFill>
+                      <a:schemeClr val="tx1"/>
+                    </a:solidFill>
+                  </a:rPr>
+                  <a:t>0 (fixed endpoints, fixed </a:t>
+                </a:r>
+                <a14:m>
+                  <m:oMath xmlns:m="http://schemas.openxmlformats.org/officeDocument/2006/math">
+                    <m:r>
+                      <a:rPr lang="en-US" sz="900" i="1" dirty="0" smtClean="0">
+                        <a:solidFill>
+                          <a:schemeClr val="tx1"/>
+                        </a:solidFill>
+                        <a:latin typeface="Cambria Math" panose="02040503050406030204" pitchFamily="18" charset="0"/>
+                      </a:rPr>
+                      <m:t>𝐸</m:t>
+                    </m:r>
+                  </m:oMath>
+                </a14:m>
+                <a:r>
+                  <a:rPr lang="en-US" sz="900" dirty="0">
+                    <a:solidFill>
+                      <a:schemeClr val="tx1"/>
+                    </a:solidFill>
+                  </a:rPr>
+                  <a:t>)</a:t>
+                </a:r>
               </a:p>
             </p:txBody>
           </p:sp>
@@ -4468,7 +4562,431 @@
               <a:blipFill>
                 <a:blip r:embed="rId4"/>
                 <a:stretch>
-                  <a:fillRect t="-49057" b="-105660"/>
+                  <a:fillRect t="-7547" b="-28302"/>
+                </a:stretch>
+              </a:blipFill>
+            </p:spPr>
+            <p:txBody>
+              <a:bodyPr/>
+              <a:lstStyle/>
+              <a:p>
+                <a:r>
+                  <a:rPr lang="en-US">
+                    <a:noFill/>
+                  </a:rPr>
+                  <a:t> </a:t>
+                </a:r>
+              </a:p>
+            </p:txBody>
+          </p:sp>
+        </mc:Fallback>
+      </mc:AlternateContent>
+      <mc:AlternateContent xmlns:mc="http://schemas.openxmlformats.org/markup-compatibility/2006">
+        <mc:Choice xmlns:a14="http://schemas.microsoft.com/office/drawing/2010/main" Requires="a14">
+          <p:sp>
+            <p:nvSpPr>
+              <p:cNvPr id="2" name="Rounded Rectangle 1">
+                <a:extLst>
+                  <a:ext uri="{FF2B5EF4-FFF2-40B4-BE49-F238E27FC236}">
+                    <a16:creationId xmlns:a16="http://schemas.microsoft.com/office/drawing/2014/main" id="{FB97858E-892C-FB1E-3C88-BB9D2EFAF859}"/>
+                  </a:ext>
+                </a:extLst>
+              </p:cNvPr>
+              <p:cNvSpPr/>
+              <p:nvPr/>
+            </p:nvSpPr>
+            <p:spPr>
+              <a:xfrm>
+                <a:off x="3191774" y="4292290"/>
+                <a:ext cx="2719458" cy="647897"/>
+              </a:xfrm>
+              <a:prstGeom prst="roundRect">
+                <a:avLst/>
+              </a:prstGeom>
+              <a:solidFill>
+                <a:schemeClr val="accent5">
+                  <a:lumMod val="40000"/>
+                  <a:lumOff val="60000"/>
+                  <a:alpha val="25882"/>
+                </a:schemeClr>
+              </a:solidFill>
+            </p:spPr>
+            <p:style>
+              <a:lnRef idx="2">
+                <a:schemeClr val="accent1">
+                  <a:shade val="15000"/>
+                </a:schemeClr>
+              </a:lnRef>
+              <a:fillRef idx="1">
+                <a:schemeClr val="accent1"/>
+              </a:fillRef>
+              <a:effectRef idx="0">
+                <a:schemeClr val="accent1"/>
+              </a:effectRef>
+              <a:fontRef idx="minor">
+                <a:schemeClr val="lt1"/>
+              </a:fontRef>
+            </p:style>
+            <p:txBody>
+              <a:bodyPr rtlCol="0" anchor="ctr"/>
+              <a:lstStyle/>
+              <a:p>
+                <a:pPr algn="ctr"/>
+                <a:r>
+                  <a:rPr lang="en-US" sz="900" dirty="0">
+                    <a:solidFill>
+                      <a:schemeClr val="tx1"/>
+                    </a:solidFill>
+                  </a:rPr>
+                  <a:t>Jacobi metric</a:t>
+                </a:r>
+              </a:p>
+              <a:p>
+                <a:pPr algn="ctr"/>
+                <a14:m>
+                  <m:oMathPara xmlns:m="http://schemas.openxmlformats.org/officeDocument/2006/math">
+                    <m:oMathParaPr>
+                      <m:jc m:val="centerGroup"/>
+                    </m:oMathParaPr>
+                    <m:oMath xmlns:m="http://schemas.openxmlformats.org/officeDocument/2006/math">
+                      <m:sSub>
+                        <m:sSubPr>
+                          <m:ctrlPr>
+                            <a:rPr lang="en-US" sz="900" i="1" smtClean="0">
+                              <a:solidFill>
+                                <a:schemeClr val="tx1"/>
+                              </a:solidFill>
+                              <a:latin typeface="Cambria Math" panose="02040503050406030204" pitchFamily="18" charset="0"/>
+                            </a:rPr>
+                          </m:ctrlPr>
+                        </m:sSubPr>
+                        <m:e>
+                          <m:r>
+                            <a:rPr lang="en-US" sz="900" b="0" i="1" smtClean="0">
+                              <a:solidFill>
+                                <a:schemeClr val="tx1"/>
+                              </a:solidFill>
+                              <a:latin typeface="Cambria Math" panose="02040503050406030204" pitchFamily="18" charset="0"/>
+                            </a:rPr>
+                            <m:t>𝐽</m:t>
+                          </m:r>
+                        </m:e>
+                        <m:sub>
+                          <m:r>
+                            <a:rPr lang="en-US" sz="900" b="0" i="1" smtClean="0">
+                              <a:solidFill>
+                                <a:schemeClr val="tx1"/>
+                              </a:solidFill>
+                              <a:latin typeface="Cambria Math" panose="02040503050406030204" pitchFamily="18" charset="0"/>
+                            </a:rPr>
+                            <m:t>𝑖𝑗</m:t>
+                          </m:r>
+                        </m:sub>
+                      </m:sSub>
+                      <m:d>
+                        <m:dPr>
+                          <m:ctrlPr>
+                            <a:rPr lang="en-US" sz="900" i="1" smtClean="0">
+                              <a:solidFill>
+                                <a:schemeClr val="tx1"/>
+                              </a:solidFill>
+                              <a:latin typeface="Cambria Math" panose="02040503050406030204" pitchFamily="18" charset="0"/>
+                            </a:rPr>
+                          </m:ctrlPr>
+                        </m:dPr>
+                        <m:e>
+                          <m:r>
+                            <a:rPr lang="en-US" sz="900" b="0" i="1" smtClean="0">
+                              <a:solidFill>
+                                <a:schemeClr val="tx1"/>
+                              </a:solidFill>
+                              <a:latin typeface="Cambria Math" panose="02040503050406030204" pitchFamily="18" charset="0"/>
+                            </a:rPr>
+                            <m:t>𝑞</m:t>
+                          </m:r>
+                          <m:r>
+                            <a:rPr lang="en-US" sz="900" b="0" i="1" smtClean="0">
+                              <a:solidFill>
+                                <a:schemeClr val="tx1"/>
+                              </a:solidFill>
+                              <a:latin typeface="Cambria Math" panose="02040503050406030204" pitchFamily="18" charset="0"/>
+                            </a:rPr>
+                            <m:t>;</m:t>
+                          </m:r>
+                          <m:r>
+                            <a:rPr lang="en-US" sz="900" b="0" i="1" smtClean="0">
+                              <a:solidFill>
+                                <a:schemeClr val="tx1"/>
+                              </a:solidFill>
+                              <a:latin typeface="Cambria Math" panose="02040503050406030204" pitchFamily="18" charset="0"/>
+                            </a:rPr>
+                            <m:t>𝐸</m:t>
+                          </m:r>
+                        </m:e>
+                      </m:d>
+                      <m:r>
+                        <a:rPr lang="en-US" sz="900" b="0" i="1" smtClean="0">
+                          <a:solidFill>
+                            <a:schemeClr val="tx1"/>
+                          </a:solidFill>
+                          <a:latin typeface="Cambria Math" panose="02040503050406030204" pitchFamily="18" charset="0"/>
+                        </a:rPr>
+                        <m:t>=2</m:t>
+                      </m:r>
+                      <m:d>
+                        <m:dPr>
+                          <m:ctrlPr>
+                            <a:rPr lang="en-US" sz="900" b="0" i="1" smtClean="0">
+                              <a:solidFill>
+                                <a:schemeClr val="tx1"/>
+                              </a:solidFill>
+                              <a:latin typeface="Cambria Math" panose="02040503050406030204" pitchFamily="18" charset="0"/>
+                            </a:rPr>
+                          </m:ctrlPr>
+                        </m:dPr>
+                        <m:e>
+                          <m:r>
+                            <a:rPr lang="en-US" sz="900" b="0" i="1" smtClean="0">
+                              <a:solidFill>
+                                <a:schemeClr val="tx1"/>
+                              </a:solidFill>
+                              <a:latin typeface="Cambria Math" panose="02040503050406030204" pitchFamily="18" charset="0"/>
+                            </a:rPr>
+                            <m:t>𝐸</m:t>
+                          </m:r>
+                          <m:r>
+                            <a:rPr lang="en-US" sz="900" b="0" i="1" smtClean="0">
+                              <a:solidFill>
+                                <a:schemeClr val="tx1"/>
+                              </a:solidFill>
+                              <a:latin typeface="Cambria Math" panose="02040503050406030204" pitchFamily="18" charset="0"/>
+                            </a:rPr>
+                            <m:t>−</m:t>
+                          </m:r>
+                          <m:r>
+                            <a:rPr lang="en-US" sz="900" b="0" i="1" smtClean="0">
+                              <a:solidFill>
+                                <a:schemeClr val="tx1"/>
+                              </a:solidFill>
+                              <a:latin typeface="Cambria Math" panose="02040503050406030204" pitchFamily="18" charset="0"/>
+                            </a:rPr>
+                            <m:t>𝑉</m:t>
+                          </m:r>
+                          <m:d>
+                            <m:dPr>
+                              <m:ctrlPr>
+                                <a:rPr lang="en-US" sz="900" b="0" i="1" smtClean="0">
+                                  <a:solidFill>
+                                    <a:schemeClr val="tx1"/>
+                                  </a:solidFill>
+                                  <a:latin typeface="Cambria Math" panose="02040503050406030204" pitchFamily="18" charset="0"/>
+                                </a:rPr>
+                              </m:ctrlPr>
+                            </m:dPr>
+                            <m:e>
+                              <m:r>
+                                <a:rPr lang="en-US" sz="900" b="0" i="1" smtClean="0">
+                                  <a:solidFill>
+                                    <a:schemeClr val="tx1"/>
+                                  </a:solidFill>
+                                  <a:latin typeface="Cambria Math" panose="02040503050406030204" pitchFamily="18" charset="0"/>
+                                </a:rPr>
+                                <m:t>𝑞</m:t>
+                              </m:r>
+                            </m:e>
+                          </m:d>
+                        </m:e>
+                      </m:d>
+                      <m:r>
+                        <a:rPr lang="en-US" sz="900" b="0" i="1" smtClean="0">
+                          <a:solidFill>
+                            <a:schemeClr val="tx1"/>
+                          </a:solidFill>
+                          <a:latin typeface="Cambria Math" panose="02040503050406030204" pitchFamily="18" charset="0"/>
+                          <a:ea typeface="Cambria Math" panose="02040503050406030204" pitchFamily="18" charset="0"/>
+                        </a:rPr>
+                        <m:t>∙</m:t>
+                      </m:r>
+                      <m:sSub>
+                        <m:sSubPr>
+                          <m:ctrlPr>
+                            <a:rPr lang="en-US" sz="900" b="0" i="1" smtClean="0">
+                              <a:solidFill>
+                                <a:schemeClr val="tx1"/>
+                              </a:solidFill>
+                              <a:latin typeface="Cambria Math" panose="02040503050406030204" pitchFamily="18" charset="0"/>
+                              <a:ea typeface="Cambria Math" panose="02040503050406030204" pitchFamily="18" charset="0"/>
+                            </a:rPr>
+                          </m:ctrlPr>
+                        </m:sSubPr>
+                        <m:e>
+                          <m:r>
+                            <a:rPr lang="en-US" sz="900" b="0" i="1" smtClean="0">
+                              <a:solidFill>
+                                <a:schemeClr val="tx1"/>
+                              </a:solidFill>
+                              <a:latin typeface="Cambria Math" panose="02040503050406030204" pitchFamily="18" charset="0"/>
+                              <a:ea typeface="Cambria Math" panose="02040503050406030204" pitchFamily="18" charset="0"/>
+                            </a:rPr>
+                            <m:t>𝑔</m:t>
+                          </m:r>
+                        </m:e>
+                        <m:sub>
+                          <m:r>
+                            <a:rPr lang="en-US" sz="900" b="0" i="1" smtClean="0">
+                              <a:solidFill>
+                                <a:schemeClr val="tx1"/>
+                              </a:solidFill>
+                              <a:latin typeface="Cambria Math" panose="02040503050406030204" pitchFamily="18" charset="0"/>
+                              <a:ea typeface="Cambria Math" panose="02040503050406030204" pitchFamily="18" charset="0"/>
+                            </a:rPr>
+                            <m:t>𝑖𝑗</m:t>
+                          </m:r>
+                        </m:sub>
+                      </m:sSub>
+                      <m:d>
+                        <m:dPr>
+                          <m:ctrlPr>
+                            <a:rPr lang="en-US" sz="900" b="0" i="1" smtClean="0">
+                              <a:solidFill>
+                                <a:schemeClr val="tx1"/>
+                              </a:solidFill>
+                              <a:latin typeface="Cambria Math" panose="02040503050406030204" pitchFamily="18" charset="0"/>
+                              <a:ea typeface="Cambria Math" panose="02040503050406030204" pitchFamily="18" charset="0"/>
+                            </a:rPr>
+                          </m:ctrlPr>
+                        </m:dPr>
+                        <m:e>
+                          <m:r>
+                            <a:rPr lang="en-US" sz="900" b="0" i="1" smtClean="0">
+                              <a:solidFill>
+                                <a:schemeClr val="tx1"/>
+                              </a:solidFill>
+                              <a:latin typeface="Cambria Math" panose="02040503050406030204" pitchFamily="18" charset="0"/>
+                              <a:ea typeface="Cambria Math" panose="02040503050406030204" pitchFamily="18" charset="0"/>
+                            </a:rPr>
+                            <m:t>𝑞</m:t>
+                          </m:r>
+                        </m:e>
+                      </m:d>
+                    </m:oMath>
+                  </m:oMathPara>
+                </a14:m>
+                <a:endParaRPr lang="en-US" sz="900" dirty="0">
+                  <a:solidFill>
+                    <a:schemeClr val="tx1"/>
+                  </a:solidFill>
+                </a:endParaRPr>
+              </a:p>
+              <a:p>
+                <a:pPr algn="ctr"/>
+                <a:r>
+                  <a:rPr lang="en-US" sz="900" dirty="0">
+                    <a:solidFill>
+                      <a:schemeClr val="tx1"/>
+                    </a:solidFill>
+                  </a:rPr>
+                  <a:t>Riemannian on </a:t>
+                </a:r>
+                <a14:m>
+                  <m:oMath xmlns:m="http://schemas.openxmlformats.org/officeDocument/2006/math">
+                    <m:sSub>
+                      <m:sSubPr>
+                        <m:ctrlPr>
+                          <a:rPr lang="en-US" sz="900" i="1" smtClean="0">
+                            <a:solidFill>
+                              <a:schemeClr val="tx1"/>
+                            </a:solidFill>
+                            <a:latin typeface="Cambria Math" panose="02040503050406030204" pitchFamily="18" charset="0"/>
+                          </a:rPr>
+                        </m:ctrlPr>
+                      </m:sSubPr>
+                      <m:e>
+                        <m:r>
+                          <a:rPr lang="en-US" sz="900" i="1" smtClean="0">
+                            <a:solidFill>
+                              <a:schemeClr val="tx1"/>
+                            </a:solidFill>
+                            <a:latin typeface="Cambria Math" panose="02040503050406030204" pitchFamily="18" charset="0"/>
+                            <a:ea typeface="Cambria Math" panose="02040503050406030204" pitchFamily="18" charset="0"/>
+                          </a:rPr>
+                          <m:t>ℳ</m:t>
+                        </m:r>
+                      </m:e>
+                      <m:sub>
+                        <m:r>
+                          <a:rPr lang="en-US" sz="900" b="0" i="1" smtClean="0">
+                            <a:solidFill>
+                              <a:schemeClr val="tx1"/>
+                            </a:solidFill>
+                            <a:latin typeface="Cambria Math" panose="02040503050406030204" pitchFamily="18" charset="0"/>
+                          </a:rPr>
+                          <m:t>𝐸</m:t>
+                        </m:r>
+                      </m:sub>
+                    </m:sSub>
+                    <m:r>
+                      <a:rPr lang="en-US" sz="900" b="0" i="1" smtClean="0">
+                        <a:solidFill>
+                          <a:schemeClr val="tx1"/>
+                        </a:solidFill>
+                        <a:latin typeface="Cambria Math" panose="02040503050406030204" pitchFamily="18" charset="0"/>
+                      </a:rPr>
+                      <m:t>=</m:t>
+                    </m:r>
+                    <m:d>
+                      <m:dPr>
+                        <m:begChr m:val="{"/>
+                        <m:endChr m:val="}"/>
+                        <m:ctrlPr>
+                          <a:rPr lang="en-US" sz="900" b="0" i="1" smtClean="0">
+                            <a:solidFill>
+                              <a:schemeClr val="tx1"/>
+                            </a:solidFill>
+                            <a:latin typeface="Cambria Math" panose="02040503050406030204" pitchFamily="18" charset="0"/>
+                          </a:rPr>
+                        </m:ctrlPr>
+                      </m:dPr>
+                      <m:e/>
+                    </m:d>
+                  </m:oMath>
+                </a14:m>
+                <a:endParaRPr lang="en-US" sz="900" dirty="0">
+                  <a:solidFill>
+                    <a:schemeClr val="tx1"/>
+                  </a:solidFill>
+                </a:endParaRPr>
+              </a:p>
+            </p:txBody>
+          </p:sp>
+        </mc:Choice>
+        <mc:Fallback>
+          <p:sp>
+            <p:nvSpPr>
+              <p:cNvPr id="2" name="Rounded Rectangle 1">
+                <a:extLst>
+                  <a:ext uri="{FF2B5EF4-FFF2-40B4-BE49-F238E27FC236}">
+                    <a16:creationId xmlns:a16="http://schemas.microsoft.com/office/drawing/2014/main" id="{FB97858E-892C-FB1E-3C88-BB9D2EFAF859}"/>
+                  </a:ext>
+                </a:extLst>
+              </p:cNvPr>
+              <p:cNvSpPr>
+                <a:spLocks noRot="1" noChangeAspect="1" noMove="1" noResize="1" noEditPoints="1" noAdjustHandles="1" noChangeArrowheads="1" noChangeShapeType="1" noTextEdit="1"/>
+              </p:cNvSpPr>
+              <p:nvPr/>
+            </p:nvSpPr>
+            <p:spPr>
+              <a:xfrm>
+                <a:off x="3191774" y="4292290"/>
+                <a:ext cx="2719458" cy="647897"/>
+              </a:xfrm>
+              <a:prstGeom prst="roundRect">
+                <a:avLst/>
+              </a:prstGeom>
+              <a:blipFill>
+                <a:blip r:embed="rId5"/>
+                <a:stretch>
+                  <a:fillRect/>
                 </a:stretch>
               </a:blipFill>
             </p:spPr>

</xml_diff>